<commit_message>
new pdf of comp. theory
</commit_message>
<xml_diff>
--- a/slides/00-DailyAnnouncements.pptx
+++ b/slides/00-DailyAnnouncements.pptx
@@ -5,7 +5,7 @@
     <p:sldMasterId id="2147484006" r:id="rId1"/>
   </p:sldMasterIdLst>
   <p:notesMasterIdLst>
-    <p:notesMasterId r:id="rId23"/>
+    <p:notesMasterId r:id="rId24"/>
   </p:notesMasterIdLst>
   <p:sldIdLst>
     <p:sldId id="256" r:id="rId2"/>
@@ -28,7 +28,8 @@
     <p:sldId id="531" r:id="rId19"/>
     <p:sldId id="532" r:id="rId20"/>
     <p:sldId id="533" r:id="rId21"/>
-    <p:sldId id="515" r:id="rId22"/>
+    <p:sldId id="534" r:id="rId22"/>
+    <p:sldId id="515" r:id="rId23"/>
   </p:sldIdLst>
   <p:sldSz cx="12192000" cy="6858000"/>
   <p:notesSz cx="6858000" cy="9144000"/>
@@ -217,7 +218,7 @@
           <a:p>
             <a:fld id="{C5B45307-6ED4-B142-BD64-10F739779302}" type="datetimeFigureOut">
               <a:rPr lang="en-US" smtClean="0"/>
-              <a:t>12/2/25</a:t>
+              <a:t>12/4/25</a:t>
             </a:fld>
             <a:endParaRPr lang="en-US"/>
           </a:p>
@@ -4850,7 +4851,7 @@
           <a:p>
             <a:fld id="{4313F670-7F9A-774D-B73D-573401E44297}" type="datetime1">
               <a:rPr lang="en-US" smtClean="0"/>
-              <a:t>12/2/25</a:t>
+              <a:t>12/4/25</a:t>
             </a:fld>
             <a:endParaRPr lang="en-US"/>
           </a:p>
@@ -5117,7 +5118,7 @@
           <a:p>
             <a:fld id="{446F9669-A8A7-2D40-9D01-B35FC337AA30}" type="datetime1">
               <a:rPr lang="en-US" smtClean="0"/>
-              <a:t>12/2/25</a:t>
+              <a:t>12/4/25</a:t>
             </a:fld>
             <a:endParaRPr lang="en-US"/>
           </a:p>
@@ -5313,7 +5314,7 @@
           <a:p>
             <a:fld id="{FA76CF18-F41B-6B48-B3E5-599E9795C2C3}" type="datetime1">
               <a:rPr lang="en-US" smtClean="0"/>
-              <a:t>12/2/25</a:t>
+              <a:t>12/4/25</a:t>
             </a:fld>
             <a:endParaRPr lang="en-US"/>
           </a:p>
@@ -5576,7 +5577,7 @@
           <a:p>
             <a:fld id="{B9654854-6457-164F-A077-6B3035079B82}" type="datetime1">
               <a:rPr lang="en-US" smtClean="0"/>
-              <a:t>12/2/25</a:t>
+              <a:t>12/4/25</a:t>
             </a:fld>
             <a:endParaRPr lang="en-US"/>
           </a:p>
@@ -6010,7 +6011,7 @@
           <a:p>
             <a:fld id="{CE3DBFD7-E611-8C40-AC73-0C29FF63F0CD}" type="datetime1">
               <a:rPr lang="en-US" smtClean="0"/>
-              <a:t>12/2/25</a:t>
+              <a:t>12/4/25</a:t>
             </a:fld>
             <a:endParaRPr lang="en-US"/>
           </a:p>
@@ -6556,7 +6557,7 @@
           <a:p>
             <a:fld id="{C8B63B06-0493-2840-9F37-30C9412BBF17}" type="datetime1">
               <a:rPr lang="en-US" smtClean="0"/>
-              <a:t>12/2/25</a:t>
+              <a:t>12/4/25</a:t>
             </a:fld>
             <a:endParaRPr lang="en-US"/>
           </a:p>
@@ -7276,7 +7277,7 @@
           <a:p>
             <a:fld id="{72B5C0FA-8C46-E84D-B6D7-B673F2CA0A0E}" type="datetime1">
               <a:rPr lang="en-US" smtClean="0"/>
-              <a:t>12/2/25</a:t>
+              <a:t>12/4/25</a:t>
             </a:fld>
             <a:endParaRPr lang="en-US"/>
           </a:p>
@@ -7446,7 +7447,7 @@
           <a:p>
             <a:fld id="{60B9CDE1-97B4-BF46-B69C-B86855B18820}" type="datetime1">
               <a:rPr lang="en-US" smtClean="0"/>
-              <a:t>12/2/25</a:t>
+              <a:t>12/4/25</a:t>
             </a:fld>
             <a:endParaRPr lang="en-US"/>
           </a:p>
@@ -7626,7 +7627,7 @@
           <a:p>
             <a:fld id="{BE51D3A4-F9E5-FD49-AA87-B395F50451DC}" type="datetime1">
               <a:rPr lang="en-US" smtClean="0"/>
-              <a:t>12/2/25</a:t>
+              <a:t>12/4/25</a:t>
             </a:fld>
             <a:endParaRPr lang="en-US"/>
           </a:p>
@@ -7796,7 +7797,7 @@
           <a:p>
             <a:fld id="{880DFB37-B0AE-9449-85EC-14F9C83B6084}" type="datetime1">
               <a:rPr lang="en-US" smtClean="0"/>
-              <a:t>12/2/25</a:t>
+              <a:t>12/4/25</a:t>
             </a:fld>
             <a:endParaRPr lang="en-US"/>
           </a:p>
@@ -8046,7 +8047,7 @@
           <a:p>
             <a:fld id="{C939124A-616E-6944-A21A-1839F5DBE7BB}" type="datetime1">
               <a:rPr lang="en-US" smtClean="0"/>
-              <a:t>12/2/25</a:t>
+              <a:t>12/4/25</a:t>
             </a:fld>
             <a:endParaRPr lang="en-US"/>
           </a:p>
@@ -8278,7 +8279,7 @@
           <a:p>
             <a:fld id="{C6E9A026-D48C-FD43-8676-CD625DD5D84B}" type="datetime1">
               <a:rPr lang="en-US" smtClean="0"/>
-              <a:t>12/2/25</a:t>
+              <a:t>12/4/25</a:t>
             </a:fld>
             <a:endParaRPr lang="en-US"/>
           </a:p>
@@ -8664,7 +8665,7 @@
           <a:p>
             <a:fld id="{EA35111E-23A3-1440-99A3-C4C665908E3D}" type="datetime1">
               <a:rPr lang="en-US" smtClean="0"/>
-              <a:t>12/2/25</a:t>
+              <a:t>12/4/25</a:t>
             </a:fld>
             <a:endParaRPr lang="en-US"/>
           </a:p>
@@ -8787,7 +8788,7 @@
           <a:p>
             <a:fld id="{249983B9-88EF-D74B-BA6D-6A3BF17C2B38}" type="datetime1">
               <a:rPr lang="en-US" smtClean="0"/>
-              <a:t>12/2/25</a:t>
+              <a:t>12/4/25</a:t>
             </a:fld>
             <a:endParaRPr lang="en-US"/>
           </a:p>
@@ -8882,7 +8883,7 @@
           <a:p>
             <a:fld id="{E2A00AEF-B4EC-084A-8DB8-A225C7981CBB}" type="datetime1">
               <a:rPr lang="en-US" smtClean="0"/>
-              <a:t>12/2/25</a:t>
+              <a:t>12/4/25</a:t>
             </a:fld>
             <a:endParaRPr lang="en-US"/>
           </a:p>
@@ -9131,7 +9132,7 @@
           <a:p>
             <a:fld id="{97860299-21CD-A94A-A7B0-44E787F8D42C}" type="datetime1">
               <a:rPr lang="en-US" smtClean="0"/>
-              <a:t>12/2/25</a:t>
+              <a:t>12/4/25</a:t>
             </a:fld>
             <a:endParaRPr lang="en-US"/>
           </a:p>
@@ -9416,7 +9417,7 @@
           <a:p>
             <a:fld id="{3DFD19CF-4E62-D246-BA61-7B528271315F}" type="datetime1">
               <a:rPr lang="en-US" smtClean="0"/>
-              <a:t>12/2/25</a:t>
+              <a:t>12/4/25</a:t>
             </a:fld>
             <a:endParaRPr lang="en-US"/>
           </a:p>
@@ -12483,7 +12484,7 @@
           <a:p>
             <a:fld id="{92FF8978-FE14-CC4A-93A6-934EB06543C0}" type="datetime1">
               <a:rPr lang="en-US" smtClean="0"/>
-              <a:t>12/2/25</a:t>
+              <a:t>12/4/25</a:t>
             </a:fld>
             <a:endParaRPr lang="en-US"/>
           </a:p>
@@ -15872,6 +15873,280 @@
   <p:cSld>
     <p:spTree>
       <p:nvGrpSpPr>
+        <p:cNvPr id="1" name="">
+          <a:extLst>
+            <a:ext uri="{FF2B5EF4-FFF2-40B4-BE49-F238E27FC236}">
+              <a16:creationId xmlns:a16="http://schemas.microsoft.com/office/drawing/2014/main" id="{A80440D3-AACD-9613-35AF-8DE0251197AC}"/>
+            </a:ext>
+          </a:extLst>
+        </p:cNvPr>
+        <p:cNvGrpSpPr/>
+        <p:nvPr/>
+      </p:nvGrpSpPr>
+      <p:grpSpPr>
+        <a:xfrm>
+          <a:off x="0" y="0"/>
+          <a:ext cx="0" cy="0"/>
+          <a:chOff x="0" y="0"/>
+          <a:chExt cx="0" cy="0"/>
+        </a:xfrm>
+      </p:grpSpPr>
+      <p:sp>
+        <p:nvSpPr>
+          <p:cNvPr id="6146" name="Rectangle 2">
+            <a:extLst>
+              <a:ext uri="{FF2B5EF4-FFF2-40B4-BE49-F238E27FC236}">
+                <a16:creationId xmlns:a16="http://schemas.microsoft.com/office/drawing/2014/main" id="{AB91B9A7-8D39-AA4D-A3D1-47ED5555CF3B}"/>
+              </a:ext>
+            </a:extLst>
+          </p:cNvPr>
+          <p:cNvSpPr>
+            <a:spLocks noGrp="1" noChangeArrowheads="1"/>
+          </p:cNvSpPr>
+          <p:nvPr>
+            <p:ph type="title"/>
+            <p:custDataLst>
+              <p:tags r:id="rId1"/>
+            </p:custDataLst>
+          </p:nvPr>
+        </p:nvSpPr>
+        <p:spPr>
+          <a:xfrm>
+            <a:off x="1141413" y="284084"/>
+            <a:ext cx="9905998" cy="620791"/>
+          </a:xfrm>
+        </p:spPr>
+        <p:txBody>
+          <a:bodyPr/>
+          <a:lstStyle/>
+          <a:p>
+            <a:pPr algn="ctr"/>
+            <a:r>
+              <a:rPr lang="en-US" dirty="0"/>
+              <a:t>Lecture 23: </a:t>
+            </a:r>
+            <a:r>
+              <a:rPr lang="en-US" dirty="0" err="1"/>
+              <a:t>THursday</a:t>
+            </a:r>
+            <a:r>
+              <a:rPr lang="en-US" dirty="0"/>
+              <a:t>, Dec 4</a:t>
+            </a:r>
+          </a:p>
+        </p:txBody>
+      </p:sp>
+      <p:sp>
+        <p:nvSpPr>
+          <p:cNvPr id="6147" name="Rectangle 3">
+            <a:extLst>
+              <a:ext uri="{FF2B5EF4-FFF2-40B4-BE49-F238E27FC236}">
+                <a16:creationId xmlns:a16="http://schemas.microsoft.com/office/drawing/2014/main" id="{87139A4B-4D58-F93D-7E27-76B8A627D27A}"/>
+              </a:ext>
+            </a:extLst>
+          </p:cNvPr>
+          <p:cNvSpPr>
+            <a:spLocks noGrp="1" noChangeArrowheads="1"/>
+          </p:cNvSpPr>
+          <p:nvPr>
+            <p:ph idx="1"/>
+            <p:custDataLst>
+              <p:tags r:id="rId2"/>
+            </p:custDataLst>
+          </p:nvPr>
+        </p:nvSpPr>
+        <p:spPr>
+          <a:xfrm>
+            <a:off x="1294151" y="1098548"/>
+            <a:ext cx="9905998" cy="5387311"/>
+          </a:xfrm>
+        </p:spPr>
+        <p:txBody>
+          <a:bodyPr>
+            <a:normAutofit fontScale="62500" lnSpcReduction="20000"/>
+          </a:bodyPr>
+          <a:lstStyle/>
+          <a:p>
+            <a:r>
+              <a:rPr lang="en-US" dirty="0">
+                <a:latin typeface="Arial" panose="020B0604020202020204" pitchFamily="34" charset="0"/>
+                <a:cs typeface="Arial" panose="020B0604020202020204" pitchFamily="34" charset="0"/>
+              </a:rPr>
+              <a:t>This is the second to last lecture!!</a:t>
+            </a:r>
+          </a:p>
+          <a:p>
+            <a:r>
+              <a:rPr lang="en-US" dirty="0">
+                <a:latin typeface="Arial" panose="020B0604020202020204" pitchFamily="34" charset="0"/>
+                <a:cs typeface="Arial" panose="020B0604020202020204" pitchFamily="34" charset="0"/>
+              </a:rPr>
+              <a:t>Module 4 homework should be finished today or tomorrow if late</a:t>
+            </a:r>
+          </a:p>
+          <a:p>
+            <a:r>
+              <a:rPr lang="en-US" dirty="0">
+                <a:latin typeface="Arial" panose="020B0604020202020204" pitchFamily="34" charset="0"/>
+                <a:cs typeface="Arial" panose="020B0604020202020204" pitchFamily="34" charset="0"/>
+              </a:rPr>
+              <a:t>Quiz 4 is returned</a:t>
+            </a:r>
+          </a:p>
+          <a:p>
+            <a:pPr lvl="1"/>
+            <a:r>
+              <a:rPr lang="en-US" dirty="0">
+                <a:latin typeface="Arial" panose="020B0604020202020204" pitchFamily="34" charset="0"/>
+                <a:cs typeface="Arial" panose="020B0604020202020204" pitchFamily="34" charset="0"/>
+              </a:rPr>
+              <a:t>Average was a bit lower this time but not bad at all.</a:t>
+            </a:r>
+          </a:p>
+          <a:p>
+            <a:r>
+              <a:rPr lang="en-US" dirty="0">
+                <a:latin typeface="Arial" panose="020B0604020202020204" pitchFamily="34" charset="0"/>
+                <a:cs typeface="Arial" panose="020B0604020202020204" pitchFamily="34" charset="0"/>
+              </a:rPr>
+              <a:t>Homework…will probably be extended for everybody. </a:t>
+            </a:r>
+          </a:p>
+          <a:p>
+            <a:pPr lvl="1"/>
+            <a:r>
+              <a:rPr lang="en-US" dirty="0">
+                <a:latin typeface="Arial" panose="020B0604020202020204" pitchFamily="34" charset="0"/>
+                <a:cs typeface="Arial" panose="020B0604020202020204" pitchFamily="34" charset="0"/>
+              </a:rPr>
+              <a:t>Stay tuned, I’m just checking with other instructors to make sure we are all in agreement.</a:t>
+            </a:r>
+          </a:p>
+          <a:p>
+            <a:r>
+              <a:rPr lang="en-US" dirty="0">
+                <a:latin typeface="Arial" panose="020B0604020202020204" pitchFamily="34" charset="0"/>
+                <a:cs typeface="Arial" panose="020B0604020202020204" pitchFamily="34" charset="0"/>
+              </a:rPr>
+              <a:t>Our final exam is on Saturday Dec. 13 from 7-10pm.</a:t>
+            </a:r>
+          </a:p>
+          <a:p>
+            <a:pPr lvl="1"/>
+            <a:r>
+              <a:rPr lang="en-US" dirty="0">
+                <a:latin typeface="Arial" panose="020B0604020202020204" pitchFamily="34" charset="0"/>
+                <a:cs typeface="Arial" panose="020B0604020202020204" pitchFamily="34" charset="0"/>
+              </a:rPr>
+              <a:t>Floryan section will be in Rice 130!! NOT our normal classroom.</a:t>
+            </a:r>
+          </a:p>
+          <a:p>
+            <a:pPr lvl="1"/>
+            <a:r>
+              <a:rPr lang="en-US" dirty="0">
+                <a:latin typeface="Arial" panose="020B0604020202020204" pitchFamily="34" charset="0"/>
+                <a:cs typeface="Arial" panose="020B0604020202020204" pitchFamily="34" charset="0"/>
+              </a:rPr>
+              <a:t>Pettit section in Mec 205!! Also NOT normal classroom.</a:t>
+            </a:r>
+          </a:p>
+          <a:p>
+            <a:pPr lvl="1"/>
+            <a:r>
+              <a:rPr lang="en-US" dirty="0">
+                <a:latin typeface="Arial" panose="020B0604020202020204" pitchFamily="34" charset="0"/>
+                <a:cs typeface="Arial" panose="020B0604020202020204" pitchFamily="34" charset="0"/>
+              </a:rPr>
+              <a:t>Remember that you will take cumulative, quiz 5, and up to two of quiz 1-4 retakes</a:t>
+            </a:r>
+          </a:p>
+          <a:p>
+            <a:r>
+              <a:rPr lang="en-US" dirty="0">
+                <a:latin typeface="Arial" panose="020B0604020202020204" pitchFamily="34" charset="0"/>
+                <a:cs typeface="Arial" panose="020B0604020202020204" pitchFamily="34" charset="0"/>
+              </a:rPr>
+              <a:t>Please remember that I am asking for NO laptop / phones!</a:t>
+            </a:r>
+          </a:p>
+          <a:p>
+            <a:pPr lvl="1"/>
+            <a:r>
+              <a:rPr lang="en-US" dirty="0">
+                <a:latin typeface="Arial" panose="020B0604020202020204" pitchFamily="34" charset="0"/>
+                <a:cs typeface="Arial" panose="020B0604020202020204" pitchFamily="34" charset="0"/>
+              </a:rPr>
+              <a:t>This makes the learning environment better for everybody. I appreciate it!</a:t>
+            </a:r>
+          </a:p>
+          <a:p>
+            <a:r>
+              <a:rPr lang="en-US" dirty="0">
+                <a:latin typeface="Arial" panose="020B0604020202020204" pitchFamily="34" charset="0"/>
+                <a:cs typeface="Arial" panose="020B0604020202020204" pitchFamily="34" charset="0"/>
+              </a:rPr>
+              <a:t>Chase will hold a final exam review session!</a:t>
+            </a:r>
+          </a:p>
+          <a:p>
+            <a:pPr lvl="1"/>
+            <a:r>
+              <a:rPr lang="en-US" dirty="0">
+                <a:latin typeface="Arial" panose="020B0604020202020204" pitchFamily="34" charset="0"/>
+                <a:cs typeface="Arial" panose="020B0604020202020204" pitchFamily="34" charset="0"/>
+              </a:rPr>
+              <a:t>Wednesday Dec. 10 at 4-5pm in Mec 205</a:t>
+            </a:r>
+          </a:p>
+          <a:p>
+            <a:r>
+              <a:rPr lang="en-US" dirty="0">
+                <a:latin typeface="Arial" panose="020B0604020202020204" pitchFamily="34" charset="0"/>
+                <a:cs typeface="Arial" panose="020B0604020202020204" pitchFamily="34" charset="0"/>
+              </a:rPr>
+              <a:t>Lecture recordings are on Panopto</a:t>
+            </a:r>
+          </a:p>
+          <a:p>
+            <a:pPr lvl="1"/>
+            <a:r>
+              <a:rPr lang="en-US" dirty="0">
+                <a:latin typeface="Arial" panose="020B0604020202020204" pitchFamily="34" charset="0"/>
+                <a:cs typeface="Arial" panose="020B0604020202020204" pitchFamily="34" charset="0"/>
+              </a:rPr>
+              <a:t>There are folders for Floryan and Pettit (little hard to find but they are there)</a:t>
+            </a:r>
+          </a:p>
+          <a:p>
+            <a:r>
+              <a:rPr lang="en-US" dirty="0">
+                <a:latin typeface="Arial" panose="020B0604020202020204" pitchFamily="34" charset="0"/>
+                <a:cs typeface="Arial" panose="020B0604020202020204" pitchFamily="34" charset="0"/>
+              </a:rPr>
+              <a:t>Today we continue with reductions!</a:t>
+            </a:r>
+          </a:p>
+        </p:txBody>
+      </p:sp>
+    </p:spTree>
+    <p:extLst>
+      <p:ext uri="{BB962C8B-B14F-4D97-AF65-F5344CB8AC3E}">
+        <p14:creationId xmlns:p14="http://schemas.microsoft.com/office/powerpoint/2010/main" val="1911655295"/>
+      </p:ext>
+    </p:extLst>
+  </p:cSld>
+  <p:clrMapOvr>
+    <a:masterClrMapping/>
+  </p:clrMapOvr>
+</p:sld>
+</file>
+
+<file path=ppt/slides/slide22.xml><?xml version="1.0" encoding="utf-8"?>
+<p:sld xmlns:a="http://schemas.openxmlformats.org/drawingml/2006/main" xmlns:r="http://schemas.openxmlformats.org/officeDocument/2006/relationships" xmlns:p="http://schemas.openxmlformats.org/presentationml/2006/main">
+  <p:cSld>
+    <p:spTree>
+      <p:nvGrpSpPr>
         <p:cNvPr id="1" name=""/>
         <p:cNvGrpSpPr/>
         <p:nvPr/>
@@ -16208,7 +16483,7 @@
           <p:nvPr>
             <p:extLst>
               <p:ext uri="{D42A27DB-BD31-4B8C-83A1-F6EECF244321}">
-                <p14:modId xmlns:p14="http://schemas.microsoft.com/office/powerpoint/2010/main" val="4288407215"/>
+                <p14:modId xmlns:p14="http://schemas.microsoft.com/office/powerpoint/2010/main" val="1250329912"/>
               </p:ext>
             </p:extLst>
           </p:nvPr>
@@ -16318,7 +16593,7 @@
                       <a:pPr algn="ctr"/>
                       <a:r>
                         <a:rPr lang="en-US" i="0" dirty="0"/>
-                        <a:t>20</a:t>
+                        <a:t>21</a:t>
                       </a:r>
                     </a:p>
                   </a:txBody>
@@ -16332,7 +16607,7 @@
                       <a:pPr algn="ctr"/>
                       <a:r>
                         <a:rPr lang="en-US" b="1" i="0" dirty="0"/>
-                        <a:t>75.0%</a:t>
+                        <a:t>71.4%</a:t>
                       </a:r>
                     </a:p>
                   </a:txBody>
@@ -17502,7 +17777,7 @@
           <p:nvPr>
             <p:extLst>
               <p:ext uri="{D42A27DB-BD31-4B8C-83A1-F6EECF244321}">
-                <p14:modId xmlns:p14="http://schemas.microsoft.com/office/powerpoint/2010/main" val="42157553"/>
+                <p14:modId xmlns:p14="http://schemas.microsoft.com/office/powerpoint/2010/main" val="158929332"/>
               </p:ext>
             </p:extLst>
           </p:nvPr>
@@ -17612,7 +17887,7 @@
                       <a:pPr algn="ctr"/>
                       <a:r>
                         <a:rPr lang="en-US" i="0" dirty="0"/>
-                        <a:t>20</a:t>
+                        <a:t>21</a:t>
                       </a:r>
                     </a:p>
                   </a:txBody>
@@ -17626,7 +17901,7 @@
                       <a:pPr algn="ctr"/>
                       <a:r>
                         <a:rPr lang="en-US" b="1" i="0" dirty="0"/>
-                        <a:t>20.0%</a:t>
+                        <a:t>19.0%</a:t>
                       </a:r>
                     </a:p>
                   </a:txBody>
@@ -19613,6 +19888,18 @@
 </file>
 
 <file path=ppt/tags/tag43.xml><?xml version="1.0" encoding="utf-8"?>
+<p:tagLst xmlns:a="http://schemas.openxmlformats.org/drawingml/2006/main" xmlns:r="http://schemas.openxmlformats.org/officeDocument/2006/relationships" xmlns:p="http://schemas.openxmlformats.org/presentationml/2006/main">
+  <p:tag name="_INSTRUCTOR VIEW19C14C36-AC8E-43BC-9DB6-C2AAF774C7DC|PANE__TAG" val="_"/>
+</p:tagLst>
+</file>
+
+<file path=ppt/tags/tag44.xml><?xml version="1.0" encoding="utf-8"?>
+<p:tagLst xmlns:a="http://schemas.openxmlformats.org/drawingml/2006/main" xmlns:r="http://schemas.openxmlformats.org/officeDocument/2006/relationships" xmlns:p="http://schemas.openxmlformats.org/presentationml/2006/main">
+  <p:tag name="_INSTRUCTOR VIEW19C14C36-AC8E-43BC-9DB6-C2AAF774C7DC|PANE__TAG" val="_"/>
+</p:tagLst>
+</file>
+
+<file path=ppt/tags/tag45.xml><?xml version="1.0" encoding="utf-8"?>
 <p:tagLst xmlns:a="http://schemas.openxmlformats.org/drawingml/2006/main" xmlns:r="http://schemas.openxmlformats.org/officeDocument/2006/relationships" xmlns:p="http://schemas.openxmlformats.org/presentationml/2006/main">
   <p:tag name="_INSTRUCTOR VIEW19C14C36-AC8E-43BC-9DB6-C2AAF774C7DC|PANE__TAG" val="_"/>
 </p:tagLst>

</xml_diff>

<commit_message>
announcements and small changes to RL slides
</commit_message>
<xml_diff>
--- a/slides/00-DailyAnnouncements.pptx
+++ b/slides/00-DailyAnnouncements.pptx
@@ -5,12 +5,13 @@
     <p:sldMasterId id="2147484006" r:id="rId1"/>
   </p:sldMasterIdLst>
   <p:notesMasterIdLst>
-    <p:notesMasterId r:id="rId5"/>
+    <p:notesMasterId r:id="rId6"/>
   </p:notesMasterIdLst>
   <p:sldIdLst>
     <p:sldId id="256" r:id="rId2"/>
     <p:sldId id="505" r:id="rId3"/>
-    <p:sldId id="515" r:id="rId4"/>
+    <p:sldId id="516" r:id="rId4"/>
+    <p:sldId id="515" r:id="rId5"/>
   </p:sldIdLst>
   <p:sldSz cx="12192000" cy="6858000"/>
   <p:notesSz cx="6858000" cy="9144000"/>
@@ -199,7 +200,7 @@
           <a:p>
             <a:fld id="{C5B45307-6ED4-B142-BD64-10F739779302}" type="datetimeFigureOut">
               <a:rPr lang="en-US" smtClean="0"/>
-              <a:t>7/14/26</a:t>
+              <a:t>7/15/26</a:t>
             </a:fld>
             <a:endParaRPr lang="en-US"/>
           </a:p>
@@ -607,7 +608,7 @@
           <a:noFill/>
           <a:extLst>
             <a:ext uri="{909E8E84-426E-40dd-AFC4-6F175D3DCCD1}">
-              <a14:hiddenFill xmlns="" xmlns:a14="http://schemas.microsoft.com/office/drawing/2010/main">
+              <a14:hiddenFill xmlns:a14="http://schemas.microsoft.com/office/drawing/2010/main" xmlns="">
                 <a:solidFill>
                   <a:srgbClr val="FFFFFF"/>
                 </a:solidFill>
@@ -666,7 +667,7 @@
             </a:ln>
             <a:extLst>
               <a:ext uri="{91240B29-F687-4f45-9708-019B960494DF}">
-                <a14:hiddenLine xmlns="" xmlns:a14="http://schemas.microsoft.com/office/drawing/2010/main" w="9525">
+                <a14:hiddenLine xmlns:a14="http://schemas.microsoft.com/office/drawing/2010/main" xmlns="" w="9525">
                   <a:solidFill>
                     <a:srgbClr val="000000"/>
                   </a:solidFill>
@@ -756,7 +757,7 @@
             </a:ln>
             <a:extLst>
               <a:ext uri="{91240B29-F687-4f45-9708-019B960494DF}">
-                <a14:hiddenLine xmlns="" xmlns:a14="http://schemas.microsoft.com/office/drawing/2010/main" w="9525">
+                <a14:hiddenLine xmlns:a14="http://schemas.microsoft.com/office/drawing/2010/main" xmlns="" w="9525">
                   <a:solidFill>
                     <a:srgbClr val="000000"/>
                   </a:solidFill>
@@ -846,7 +847,7 @@
             </a:ln>
             <a:extLst>
               <a:ext uri="{91240B29-F687-4f45-9708-019B960494DF}">
-                <a14:hiddenLine xmlns="" xmlns:a14="http://schemas.microsoft.com/office/drawing/2010/main" w="9525">
+                <a14:hiddenLine xmlns:a14="http://schemas.microsoft.com/office/drawing/2010/main" xmlns="" w="9525">
                   <a:solidFill>
                     <a:srgbClr val="000000"/>
                   </a:solidFill>
@@ -880,7 +881,7 @@
             </a:ln>
             <a:extLst>
               <a:ext uri="{91240B29-F687-4f45-9708-019B960494DF}">
-                <a14:hiddenLine xmlns="" xmlns:a14="http://schemas.microsoft.com/office/drawing/2010/main" w="9525">
+                <a14:hiddenLine xmlns:a14="http://schemas.microsoft.com/office/drawing/2010/main" xmlns="" w="9525">
                   <a:solidFill>
                     <a:srgbClr val="000000"/>
                   </a:solidFill>
@@ -970,7 +971,7 @@
             </a:ln>
             <a:extLst>
               <a:ext uri="{91240B29-F687-4f45-9708-019B960494DF}">
-                <a14:hiddenLine xmlns="" xmlns:a14="http://schemas.microsoft.com/office/drawing/2010/main" w="9525">
+                <a14:hiddenLine xmlns:a14="http://schemas.microsoft.com/office/drawing/2010/main" xmlns="" w="9525">
                   <a:solidFill>
                     <a:srgbClr val="000000"/>
                   </a:solidFill>
@@ -1032,7 +1033,7 @@
             </a:ln>
             <a:extLst>
               <a:ext uri="{91240B29-F687-4f45-9708-019B960494DF}">
-                <a14:hiddenLine xmlns="" xmlns:a14="http://schemas.microsoft.com/office/drawing/2010/main" w="9525">
+                <a14:hiddenLine xmlns:a14="http://schemas.microsoft.com/office/drawing/2010/main" xmlns="" w="9525">
                   <a:solidFill>
                     <a:srgbClr val="000000"/>
                   </a:solidFill>
@@ -1094,7 +1095,7 @@
             </a:ln>
             <a:extLst>
               <a:ext uri="{91240B29-F687-4f45-9708-019B960494DF}">
-                <a14:hiddenLine xmlns="" xmlns:a14="http://schemas.microsoft.com/office/drawing/2010/main" w="9525">
+                <a14:hiddenLine xmlns:a14="http://schemas.microsoft.com/office/drawing/2010/main" xmlns="" w="9525">
                   <a:solidFill>
                     <a:srgbClr val="000000"/>
                   </a:solidFill>
@@ -1184,7 +1185,7 @@
             </a:ln>
             <a:extLst>
               <a:ext uri="{91240B29-F687-4f45-9708-019B960494DF}">
-                <a14:hiddenLine xmlns="" xmlns:a14="http://schemas.microsoft.com/office/drawing/2010/main" w="9525">
+                <a14:hiddenLine xmlns:a14="http://schemas.microsoft.com/office/drawing/2010/main" xmlns="" w="9525">
                   <a:solidFill>
                     <a:srgbClr val="000000"/>
                   </a:solidFill>
@@ -1246,7 +1247,7 @@
             </a:ln>
             <a:extLst>
               <a:ext uri="{91240B29-F687-4f45-9708-019B960494DF}">
-                <a14:hiddenLine xmlns="" xmlns:a14="http://schemas.microsoft.com/office/drawing/2010/main" w="9525">
+                <a14:hiddenLine xmlns:a14="http://schemas.microsoft.com/office/drawing/2010/main" xmlns="" w="9525">
                   <a:solidFill>
                     <a:srgbClr val="000000"/>
                   </a:solidFill>
@@ -1308,7 +1309,7 @@
             </a:ln>
             <a:extLst>
               <a:ext uri="{91240B29-F687-4f45-9708-019B960494DF}">
-                <a14:hiddenLine xmlns="" xmlns:a14="http://schemas.microsoft.com/office/drawing/2010/main" w="9525">
+                <a14:hiddenLine xmlns:a14="http://schemas.microsoft.com/office/drawing/2010/main" xmlns="" w="9525">
                   <a:solidFill>
                     <a:srgbClr val="000000"/>
                   </a:solidFill>
@@ -1398,7 +1399,7 @@
             </a:ln>
             <a:extLst>
               <a:ext uri="{91240B29-F687-4f45-9708-019B960494DF}">
-                <a14:hiddenLine xmlns="" xmlns:a14="http://schemas.microsoft.com/office/drawing/2010/main" w="9525">
+                <a14:hiddenLine xmlns:a14="http://schemas.microsoft.com/office/drawing/2010/main" xmlns="" w="9525">
                   <a:solidFill>
                     <a:srgbClr val="000000"/>
                   </a:solidFill>
@@ -1488,7 +1489,7 @@
             </a:ln>
             <a:extLst>
               <a:ext uri="{91240B29-F687-4f45-9708-019B960494DF}">
-                <a14:hiddenLine xmlns="" xmlns:a14="http://schemas.microsoft.com/office/drawing/2010/main" w="9525">
+                <a14:hiddenLine xmlns:a14="http://schemas.microsoft.com/office/drawing/2010/main" xmlns="" w="9525">
                   <a:solidFill>
                     <a:srgbClr val="000000"/>
                   </a:solidFill>
@@ -1550,7 +1551,7 @@
             </a:ln>
             <a:extLst>
               <a:ext uri="{91240B29-F687-4f45-9708-019B960494DF}">
-                <a14:hiddenLine xmlns="" xmlns:a14="http://schemas.microsoft.com/office/drawing/2010/main" w="9525">
+                <a14:hiddenLine xmlns:a14="http://schemas.microsoft.com/office/drawing/2010/main" xmlns="" w="9525">
                   <a:solidFill>
                     <a:srgbClr val="000000"/>
                   </a:solidFill>
@@ -1660,7 +1661,7 @@
             </a:ln>
             <a:extLst>
               <a:ext uri="{91240B29-F687-4f45-9708-019B960494DF}">
-                <a14:hiddenLine xmlns="" xmlns:a14="http://schemas.microsoft.com/office/drawing/2010/main" w="9525">
+                <a14:hiddenLine xmlns:a14="http://schemas.microsoft.com/office/drawing/2010/main" xmlns="" w="9525">
                   <a:solidFill>
                     <a:srgbClr val="000000"/>
                   </a:solidFill>
@@ -1722,7 +1723,7 @@
             </a:ln>
             <a:extLst>
               <a:ext uri="{91240B29-F687-4f45-9708-019B960494DF}">
-                <a14:hiddenLine xmlns="" xmlns:a14="http://schemas.microsoft.com/office/drawing/2010/main" w="9525">
+                <a14:hiddenLine xmlns:a14="http://schemas.microsoft.com/office/drawing/2010/main" xmlns="" w="9525">
                   <a:solidFill>
                     <a:srgbClr val="000000"/>
                   </a:solidFill>
@@ -1812,7 +1813,7 @@
             </a:ln>
             <a:extLst>
               <a:ext uri="{91240B29-F687-4f45-9708-019B960494DF}">
-                <a14:hiddenLine xmlns="" xmlns:a14="http://schemas.microsoft.com/office/drawing/2010/main" w="9525">
+                <a14:hiddenLine xmlns:a14="http://schemas.microsoft.com/office/drawing/2010/main" xmlns="" w="9525">
                   <a:solidFill>
                     <a:srgbClr val="000000"/>
                   </a:solidFill>
@@ -1902,7 +1903,7 @@
             </a:ln>
             <a:extLst>
               <a:ext uri="{91240B29-F687-4f45-9708-019B960494DF}">
-                <a14:hiddenLine xmlns="" xmlns:a14="http://schemas.microsoft.com/office/drawing/2010/main" w="9525">
+                <a14:hiddenLine xmlns:a14="http://schemas.microsoft.com/office/drawing/2010/main" xmlns="" w="9525">
                   <a:solidFill>
                     <a:srgbClr val="000000"/>
                   </a:solidFill>
@@ -1964,7 +1965,7 @@
             </a:ln>
             <a:extLst>
               <a:ext uri="{91240B29-F687-4f45-9708-019B960494DF}">
-                <a14:hiddenLine xmlns="" xmlns:a14="http://schemas.microsoft.com/office/drawing/2010/main" w="9525">
+                <a14:hiddenLine xmlns:a14="http://schemas.microsoft.com/office/drawing/2010/main" xmlns="" w="9525">
                   <a:solidFill>
                     <a:srgbClr val="000000"/>
                   </a:solidFill>
@@ -2054,7 +2055,7 @@
             </a:ln>
             <a:extLst>
               <a:ext uri="{91240B29-F687-4f45-9708-019B960494DF}">
-                <a14:hiddenLine xmlns="" xmlns:a14="http://schemas.microsoft.com/office/drawing/2010/main" w="9525">
+                <a14:hiddenLine xmlns:a14="http://schemas.microsoft.com/office/drawing/2010/main" xmlns="" w="9525">
                   <a:solidFill>
                     <a:srgbClr val="000000"/>
                   </a:solidFill>
@@ -2144,7 +2145,7 @@
             </a:ln>
             <a:extLst>
               <a:ext uri="{91240B29-F687-4f45-9708-019B960494DF}">
-                <a14:hiddenLine xmlns="" xmlns:a14="http://schemas.microsoft.com/office/drawing/2010/main" w="9525">
+                <a14:hiddenLine xmlns:a14="http://schemas.microsoft.com/office/drawing/2010/main" xmlns="" w="9525">
                   <a:solidFill>
                     <a:srgbClr val="000000"/>
                   </a:solidFill>
@@ -2200,7 +2201,7 @@
             </a:ln>
             <a:extLst>
               <a:ext uri="{91240B29-F687-4f45-9708-019B960494DF}">
-                <a14:hiddenLine xmlns="" xmlns:a14="http://schemas.microsoft.com/office/drawing/2010/main" w="9525">
+                <a14:hiddenLine xmlns:a14="http://schemas.microsoft.com/office/drawing/2010/main" xmlns="" w="9525">
                   <a:solidFill>
                     <a:srgbClr val="000000"/>
                   </a:solidFill>
@@ -2290,7 +2291,7 @@
             </a:ln>
             <a:extLst>
               <a:ext uri="{91240B29-F687-4f45-9708-019B960494DF}">
-                <a14:hiddenLine xmlns="" xmlns:a14="http://schemas.microsoft.com/office/drawing/2010/main" w="9525">
+                <a14:hiddenLine xmlns:a14="http://schemas.microsoft.com/office/drawing/2010/main" xmlns="" w="9525">
                   <a:solidFill>
                     <a:srgbClr val="000000"/>
                   </a:solidFill>
@@ -2346,7 +2347,7 @@
             </a:ln>
             <a:extLst>
               <a:ext uri="{91240B29-F687-4f45-9708-019B960494DF}">
-                <a14:hiddenLine xmlns="" xmlns:a14="http://schemas.microsoft.com/office/drawing/2010/main" w="9525">
+                <a14:hiddenLine xmlns:a14="http://schemas.microsoft.com/office/drawing/2010/main" xmlns="" w="9525">
                   <a:solidFill>
                     <a:srgbClr val="000000"/>
                   </a:solidFill>
@@ -2436,7 +2437,7 @@
             </a:ln>
             <a:extLst>
               <a:ext uri="{91240B29-F687-4f45-9708-019B960494DF}">
-                <a14:hiddenLine xmlns="" xmlns:a14="http://schemas.microsoft.com/office/drawing/2010/main" w="9525">
+                <a14:hiddenLine xmlns:a14="http://schemas.microsoft.com/office/drawing/2010/main" xmlns="" w="9525">
                   <a:solidFill>
                     <a:srgbClr val="000000"/>
                   </a:solidFill>
@@ -2504,7 +2505,7 @@
             </a:ln>
             <a:extLst>
               <a:ext uri="{91240B29-F687-4f45-9708-019B960494DF}">
-                <a14:hiddenLine xmlns="" xmlns:a14="http://schemas.microsoft.com/office/drawing/2010/main" w="9525">
+                <a14:hiddenLine xmlns:a14="http://schemas.microsoft.com/office/drawing/2010/main" xmlns="" w="9525">
                   <a:solidFill>
                     <a:srgbClr val="000000"/>
                   </a:solidFill>
@@ -2594,7 +2595,7 @@
             </a:ln>
             <a:extLst>
               <a:ext uri="{91240B29-F687-4f45-9708-019B960494DF}">
-                <a14:hiddenLine xmlns="" xmlns:a14="http://schemas.microsoft.com/office/drawing/2010/main" w="9525">
+                <a14:hiddenLine xmlns:a14="http://schemas.microsoft.com/office/drawing/2010/main" xmlns="" w="9525">
                   <a:solidFill>
                     <a:srgbClr val="000000"/>
                   </a:solidFill>
@@ -2662,7 +2663,7 @@
             </a:ln>
             <a:extLst>
               <a:ext uri="{91240B29-F687-4f45-9708-019B960494DF}">
-                <a14:hiddenLine xmlns="" xmlns:a14="http://schemas.microsoft.com/office/drawing/2010/main" w="9525">
+                <a14:hiddenLine xmlns:a14="http://schemas.microsoft.com/office/drawing/2010/main" xmlns="" w="9525">
                   <a:solidFill>
                     <a:srgbClr val="000000"/>
                   </a:solidFill>
@@ -2752,7 +2753,7 @@
             </a:ln>
             <a:extLst>
               <a:ext uri="{91240B29-F687-4f45-9708-019B960494DF}">
-                <a14:hiddenLine xmlns="" xmlns:a14="http://schemas.microsoft.com/office/drawing/2010/main" w="9525">
+                <a14:hiddenLine xmlns:a14="http://schemas.microsoft.com/office/drawing/2010/main" xmlns="" w="9525">
                   <a:solidFill>
                     <a:srgbClr val="000000"/>
                   </a:solidFill>
@@ -2786,7 +2787,7 @@
             </a:ln>
             <a:extLst>
               <a:ext uri="{91240B29-F687-4f45-9708-019B960494DF}">
-                <a14:hiddenLine xmlns="" xmlns:a14="http://schemas.microsoft.com/office/drawing/2010/main" w="9525">
+                <a14:hiddenLine xmlns:a14="http://schemas.microsoft.com/office/drawing/2010/main" xmlns="" w="9525">
                   <a:solidFill>
                     <a:srgbClr val="000000"/>
                   </a:solidFill>
@@ -2876,7 +2877,7 @@
             </a:ln>
             <a:extLst>
               <a:ext uri="{91240B29-F687-4f45-9708-019B960494DF}">
-                <a14:hiddenLine xmlns="" xmlns:a14="http://schemas.microsoft.com/office/drawing/2010/main" w="9525">
+                <a14:hiddenLine xmlns:a14="http://schemas.microsoft.com/office/drawing/2010/main" xmlns="" w="9525">
                   <a:solidFill>
                     <a:srgbClr val="000000"/>
                   </a:solidFill>
@@ -2938,7 +2939,7 @@
             </a:ln>
             <a:extLst>
               <a:ext uri="{91240B29-F687-4f45-9708-019B960494DF}">
-                <a14:hiddenLine xmlns="" xmlns:a14="http://schemas.microsoft.com/office/drawing/2010/main" w="9525">
+                <a14:hiddenLine xmlns:a14="http://schemas.microsoft.com/office/drawing/2010/main" xmlns="" w="9525">
                   <a:solidFill>
                     <a:srgbClr val="000000"/>
                   </a:solidFill>
@@ -3000,7 +3001,7 @@
             </a:ln>
             <a:extLst>
               <a:ext uri="{91240B29-F687-4f45-9708-019B960494DF}">
-                <a14:hiddenLine xmlns="" xmlns:a14="http://schemas.microsoft.com/office/drawing/2010/main" w="9525">
+                <a14:hiddenLine xmlns:a14="http://schemas.microsoft.com/office/drawing/2010/main" xmlns="" w="9525">
                   <a:solidFill>
                     <a:srgbClr val="000000"/>
                   </a:solidFill>
@@ -3090,7 +3091,7 @@
             </a:ln>
             <a:extLst>
               <a:ext uri="{91240B29-F687-4f45-9708-019B960494DF}">
-                <a14:hiddenLine xmlns="" xmlns:a14="http://schemas.microsoft.com/office/drawing/2010/main" w="9525">
+                <a14:hiddenLine xmlns:a14="http://schemas.microsoft.com/office/drawing/2010/main" xmlns="" w="9525">
                   <a:solidFill>
                     <a:srgbClr val="000000"/>
                   </a:solidFill>
@@ -3158,7 +3159,7 @@
             </a:ln>
             <a:extLst>
               <a:ext uri="{91240B29-F687-4f45-9708-019B960494DF}">
-                <a14:hiddenLine xmlns="" xmlns:a14="http://schemas.microsoft.com/office/drawing/2010/main" w="9525">
+                <a14:hiddenLine xmlns:a14="http://schemas.microsoft.com/office/drawing/2010/main" xmlns="" w="9525">
                   <a:solidFill>
                     <a:srgbClr val="000000"/>
                   </a:solidFill>
@@ -3220,7 +3221,7 @@
             </a:ln>
             <a:extLst>
               <a:ext uri="{91240B29-F687-4f45-9708-019B960494DF}">
-                <a14:hiddenLine xmlns="" xmlns:a14="http://schemas.microsoft.com/office/drawing/2010/main" w="9525">
+                <a14:hiddenLine xmlns:a14="http://schemas.microsoft.com/office/drawing/2010/main" xmlns="" w="9525">
                   <a:solidFill>
                     <a:srgbClr val="000000"/>
                   </a:solidFill>
@@ -3310,7 +3311,7 @@
             </a:ln>
             <a:extLst>
               <a:ext uri="{91240B29-F687-4f45-9708-019B960494DF}">
-                <a14:hiddenLine xmlns="" xmlns:a14="http://schemas.microsoft.com/office/drawing/2010/main" w="9525">
+                <a14:hiddenLine xmlns:a14="http://schemas.microsoft.com/office/drawing/2010/main" xmlns="" w="9525">
                   <a:solidFill>
                     <a:srgbClr val="000000"/>
                   </a:solidFill>
@@ -3372,7 +3373,7 @@
             </a:ln>
             <a:extLst>
               <a:ext uri="{91240B29-F687-4f45-9708-019B960494DF}">
-                <a14:hiddenLine xmlns="" xmlns:a14="http://schemas.microsoft.com/office/drawing/2010/main" w="9525">
+                <a14:hiddenLine xmlns:a14="http://schemas.microsoft.com/office/drawing/2010/main" xmlns="" w="9525">
                   <a:solidFill>
                     <a:srgbClr val="000000"/>
                   </a:solidFill>
@@ -3462,7 +3463,7 @@
             </a:ln>
             <a:extLst>
               <a:ext uri="{91240B29-F687-4f45-9708-019B960494DF}">
-                <a14:hiddenLine xmlns="" xmlns:a14="http://schemas.microsoft.com/office/drawing/2010/main" w="9525">
+                <a14:hiddenLine xmlns:a14="http://schemas.microsoft.com/office/drawing/2010/main" xmlns="" w="9525">
                   <a:solidFill>
                     <a:srgbClr val="000000"/>
                   </a:solidFill>
@@ -3524,7 +3525,7 @@
             </a:ln>
             <a:extLst>
               <a:ext uri="{91240B29-F687-4f45-9708-019B960494DF}">
-                <a14:hiddenLine xmlns="" xmlns:a14="http://schemas.microsoft.com/office/drawing/2010/main" w="9525">
+                <a14:hiddenLine xmlns:a14="http://schemas.microsoft.com/office/drawing/2010/main" xmlns="" w="9525">
                   <a:solidFill>
                     <a:srgbClr val="000000"/>
                   </a:solidFill>
@@ -3614,7 +3615,7 @@
             </a:ln>
             <a:extLst>
               <a:ext uri="{91240B29-F687-4f45-9708-019B960494DF}">
-                <a14:hiddenLine xmlns="" xmlns:a14="http://schemas.microsoft.com/office/drawing/2010/main" w="9525">
+                <a14:hiddenLine xmlns:a14="http://schemas.microsoft.com/office/drawing/2010/main" xmlns="" w="9525">
                   <a:solidFill>
                     <a:srgbClr val="000000"/>
                   </a:solidFill>
@@ -3648,7 +3649,7 @@
             </a:ln>
             <a:extLst>
               <a:ext uri="{91240B29-F687-4f45-9708-019B960494DF}">
-                <a14:hiddenLine xmlns="" xmlns:a14="http://schemas.microsoft.com/office/drawing/2010/main" w="9525">
+                <a14:hiddenLine xmlns:a14="http://schemas.microsoft.com/office/drawing/2010/main" xmlns="" w="9525">
                   <a:solidFill>
                     <a:srgbClr val="000000"/>
                   </a:solidFill>
@@ -3713,7 +3714,7 @@
             </a:ln>
             <a:extLst>
               <a:ext uri="{91240B29-F687-4f45-9708-019B960494DF}">
-                <a14:hiddenLine xmlns="" xmlns:a14="http://schemas.microsoft.com/office/drawing/2010/main" w="9525">
+                <a14:hiddenLine xmlns:a14="http://schemas.microsoft.com/office/drawing/2010/main" xmlns="" w="9525">
                   <a:solidFill>
                     <a:srgbClr val="000000"/>
                   </a:solidFill>
@@ -3803,7 +3804,7 @@
             </a:ln>
             <a:extLst>
               <a:ext uri="{91240B29-F687-4f45-9708-019B960494DF}">
-                <a14:hiddenLine xmlns="" xmlns:a14="http://schemas.microsoft.com/office/drawing/2010/main" w="9525">
+                <a14:hiddenLine xmlns:a14="http://schemas.microsoft.com/office/drawing/2010/main" xmlns="" w="9525">
                   <a:solidFill>
                     <a:srgbClr val="000000"/>
                   </a:solidFill>
@@ -3865,7 +3866,7 @@
             </a:ln>
             <a:extLst>
               <a:ext uri="{91240B29-F687-4f45-9708-019B960494DF}">
-                <a14:hiddenLine xmlns="" xmlns:a14="http://schemas.microsoft.com/office/drawing/2010/main" w="9525">
+                <a14:hiddenLine xmlns:a14="http://schemas.microsoft.com/office/drawing/2010/main" xmlns="" w="9525">
                   <a:solidFill>
                     <a:srgbClr val="000000"/>
                   </a:solidFill>
@@ -3955,7 +3956,7 @@
             </a:ln>
             <a:extLst>
               <a:ext uri="{91240B29-F687-4f45-9708-019B960494DF}">
-                <a14:hiddenLine xmlns="" xmlns:a14="http://schemas.microsoft.com/office/drawing/2010/main" w="9525">
+                <a14:hiddenLine xmlns:a14="http://schemas.microsoft.com/office/drawing/2010/main" xmlns="" w="9525">
                   <a:solidFill>
                     <a:srgbClr val="000000"/>
                   </a:solidFill>
@@ -4045,7 +4046,7 @@
             </a:ln>
             <a:extLst>
               <a:ext uri="{91240B29-F687-4f45-9708-019B960494DF}">
-                <a14:hiddenLine xmlns="" xmlns:a14="http://schemas.microsoft.com/office/drawing/2010/main" w="9525">
+                <a14:hiddenLine xmlns:a14="http://schemas.microsoft.com/office/drawing/2010/main" xmlns="" w="9525">
                   <a:solidFill>
                     <a:srgbClr val="000000"/>
                   </a:solidFill>
@@ -4110,7 +4111,7 @@
             </a:ln>
             <a:extLst>
               <a:ext uri="{91240B29-F687-4f45-9708-019B960494DF}">
-                <a14:hiddenLine xmlns="" xmlns:a14="http://schemas.microsoft.com/office/drawing/2010/main" w="9525">
+                <a14:hiddenLine xmlns:a14="http://schemas.microsoft.com/office/drawing/2010/main" xmlns="" w="9525">
                   <a:solidFill>
                     <a:srgbClr val="000000"/>
                   </a:solidFill>
@@ -4172,7 +4173,7 @@
             </a:ln>
             <a:extLst>
               <a:ext uri="{91240B29-F687-4f45-9708-019B960494DF}">
-                <a14:hiddenLine xmlns="" xmlns:a14="http://schemas.microsoft.com/office/drawing/2010/main" w="9525">
+                <a14:hiddenLine xmlns:a14="http://schemas.microsoft.com/office/drawing/2010/main" xmlns="" w="9525">
                   <a:solidFill>
                     <a:srgbClr val="000000"/>
                   </a:solidFill>
@@ -4262,7 +4263,7 @@
             </a:ln>
             <a:extLst>
               <a:ext uri="{91240B29-F687-4f45-9708-019B960494DF}">
-                <a14:hiddenLine xmlns="" xmlns:a14="http://schemas.microsoft.com/office/drawing/2010/main" w="9525">
+                <a14:hiddenLine xmlns:a14="http://schemas.microsoft.com/office/drawing/2010/main" xmlns="" w="9525">
                   <a:solidFill>
                     <a:srgbClr val="000000"/>
                   </a:solidFill>
@@ -4352,7 +4353,7 @@
             </a:ln>
             <a:extLst>
               <a:ext uri="{91240B29-F687-4f45-9708-019B960494DF}">
-                <a14:hiddenLine xmlns="" xmlns:a14="http://schemas.microsoft.com/office/drawing/2010/main" w="9525">
+                <a14:hiddenLine xmlns:a14="http://schemas.microsoft.com/office/drawing/2010/main" xmlns="" w="9525">
                   <a:solidFill>
                     <a:srgbClr val="000000"/>
                   </a:solidFill>
@@ -4414,7 +4415,7 @@
             </a:ln>
             <a:extLst>
               <a:ext uri="{91240B29-F687-4f45-9708-019B960494DF}">
-                <a14:hiddenLine xmlns="" xmlns:a14="http://schemas.microsoft.com/office/drawing/2010/main" w="9525">
+                <a14:hiddenLine xmlns:a14="http://schemas.microsoft.com/office/drawing/2010/main" xmlns="" w="9525">
                   <a:solidFill>
                     <a:srgbClr val="000000"/>
                   </a:solidFill>
@@ -4534,7 +4535,7 @@
             </a:ln>
             <a:extLst>
               <a:ext uri="{91240B29-F687-4f45-9708-019B960494DF}">
-                <a14:hiddenLine xmlns="" xmlns:a14="http://schemas.microsoft.com/office/drawing/2010/main" w="9525">
+                <a14:hiddenLine xmlns:a14="http://schemas.microsoft.com/office/drawing/2010/main" xmlns="" w="9525">
                   <a:solidFill>
                     <a:srgbClr val="000000"/>
                   </a:solidFill>
@@ -4602,7 +4603,7 @@
             </a:ln>
             <a:extLst>
               <a:ext uri="{91240B29-F687-4f45-9708-019B960494DF}">
-                <a14:hiddenLine xmlns="" xmlns:a14="http://schemas.microsoft.com/office/drawing/2010/main" w="9525">
+                <a14:hiddenLine xmlns:a14="http://schemas.microsoft.com/office/drawing/2010/main" xmlns="" w="9525">
                   <a:solidFill>
                     <a:srgbClr val="000000"/>
                   </a:solidFill>
@@ -4692,7 +4693,7 @@
             </a:ln>
             <a:extLst>
               <a:ext uri="{91240B29-F687-4f45-9708-019B960494DF}">
-                <a14:hiddenLine xmlns="" xmlns:a14="http://schemas.microsoft.com/office/drawing/2010/main" w="9525">
+                <a14:hiddenLine xmlns:a14="http://schemas.microsoft.com/office/drawing/2010/main" xmlns="" w="9525">
                   <a:solidFill>
                     <a:srgbClr val="000000"/>
                   </a:solidFill>
@@ -4832,7 +4833,7 @@
           <a:p>
             <a:fld id="{4313F670-7F9A-774D-B73D-573401E44297}" type="datetime1">
               <a:rPr lang="en-US" smtClean="0"/>
-              <a:t>7/14/26</a:t>
+              <a:t>7/15/26</a:t>
             </a:fld>
             <a:endParaRPr lang="en-US"/>
           </a:p>
@@ -5099,7 +5100,7 @@
           <a:p>
             <a:fld id="{446F9669-A8A7-2D40-9D01-B35FC337AA30}" type="datetime1">
               <a:rPr lang="en-US" smtClean="0"/>
-              <a:t>7/14/26</a:t>
+              <a:t>7/15/26</a:t>
             </a:fld>
             <a:endParaRPr lang="en-US"/>
           </a:p>
@@ -5295,7 +5296,7 @@
           <a:p>
             <a:fld id="{FA76CF18-F41B-6B48-B3E5-599E9795C2C3}" type="datetime1">
               <a:rPr lang="en-US" smtClean="0"/>
-              <a:t>7/14/26</a:t>
+              <a:t>7/15/26</a:t>
             </a:fld>
             <a:endParaRPr lang="en-US"/>
           </a:p>
@@ -5558,7 +5559,7 @@
           <a:p>
             <a:fld id="{B9654854-6457-164F-A077-6B3035079B82}" type="datetime1">
               <a:rPr lang="en-US" smtClean="0"/>
-              <a:t>7/14/26</a:t>
+              <a:t>7/15/26</a:t>
             </a:fld>
             <a:endParaRPr lang="en-US"/>
           </a:p>
@@ -5992,7 +5993,7 @@
           <a:p>
             <a:fld id="{CE3DBFD7-E611-8C40-AC73-0C29FF63F0CD}" type="datetime1">
               <a:rPr lang="en-US" smtClean="0"/>
-              <a:t>7/14/26</a:t>
+              <a:t>7/15/26</a:t>
             </a:fld>
             <a:endParaRPr lang="en-US"/>
           </a:p>
@@ -6538,7 +6539,7 @@
           <a:p>
             <a:fld id="{C8B63B06-0493-2840-9F37-30C9412BBF17}" type="datetime1">
               <a:rPr lang="en-US" smtClean="0"/>
-              <a:t>7/14/26</a:t>
+              <a:t>7/15/26</a:t>
             </a:fld>
             <a:endParaRPr lang="en-US"/>
           </a:p>
@@ -7258,7 +7259,7 @@
           <a:p>
             <a:fld id="{72B5C0FA-8C46-E84D-B6D7-B673F2CA0A0E}" type="datetime1">
               <a:rPr lang="en-US" smtClean="0"/>
-              <a:t>7/14/26</a:t>
+              <a:t>7/15/26</a:t>
             </a:fld>
             <a:endParaRPr lang="en-US"/>
           </a:p>
@@ -7428,7 +7429,7 @@
           <a:p>
             <a:fld id="{60B9CDE1-97B4-BF46-B69C-B86855B18820}" type="datetime1">
               <a:rPr lang="en-US" smtClean="0"/>
-              <a:t>7/14/26</a:t>
+              <a:t>7/15/26</a:t>
             </a:fld>
             <a:endParaRPr lang="en-US"/>
           </a:p>
@@ -7608,7 +7609,7 @@
           <a:p>
             <a:fld id="{BE51D3A4-F9E5-FD49-AA87-B395F50451DC}" type="datetime1">
               <a:rPr lang="en-US" smtClean="0"/>
-              <a:t>7/14/26</a:t>
+              <a:t>7/15/26</a:t>
             </a:fld>
             <a:endParaRPr lang="en-US"/>
           </a:p>
@@ -7778,7 +7779,7 @@
           <a:p>
             <a:fld id="{880DFB37-B0AE-9449-85EC-14F9C83B6084}" type="datetime1">
               <a:rPr lang="en-US" smtClean="0"/>
-              <a:t>7/14/26</a:t>
+              <a:t>7/15/26</a:t>
             </a:fld>
             <a:endParaRPr lang="en-US"/>
           </a:p>
@@ -8028,7 +8029,7 @@
           <a:p>
             <a:fld id="{C939124A-616E-6944-A21A-1839F5DBE7BB}" type="datetime1">
               <a:rPr lang="en-US" smtClean="0"/>
-              <a:t>7/14/26</a:t>
+              <a:t>7/15/26</a:t>
             </a:fld>
             <a:endParaRPr lang="en-US"/>
           </a:p>
@@ -8260,7 +8261,7 @@
           <a:p>
             <a:fld id="{C6E9A026-D48C-FD43-8676-CD625DD5D84B}" type="datetime1">
               <a:rPr lang="en-US" smtClean="0"/>
-              <a:t>7/14/26</a:t>
+              <a:t>7/15/26</a:t>
             </a:fld>
             <a:endParaRPr lang="en-US"/>
           </a:p>
@@ -8646,7 +8647,7 @@
           <a:p>
             <a:fld id="{EA35111E-23A3-1440-99A3-C4C665908E3D}" type="datetime1">
               <a:rPr lang="en-US" smtClean="0"/>
-              <a:t>7/14/26</a:t>
+              <a:t>7/15/26</a:t>
             </a:fld>
             <a:endParaRPr lang="en-US"/>
           </a:p>
@@ -8769,7 +8770,7 @@
           <a:p>
             <a:fld id="{249983B9-88EF-D74B-BA6D-6A3BF17C2B38}" type="datetime1">
               <a:rPr lang="en-US" smtClean="0"/>
-              <a:t>7/14/26</a:t>
+              <a:t>7/15/26</a:t>
             </a:fld>
             <a:endParaRPr lang="en-US"/>
           </a:p>
@@ -8864,7 +8865,7 @@
           <a:p>
             <a:fld id="{E2A00AEF-B4EC-084A-8DB8-A225C7981CBB}" type="datetime1">
               <a:rPr lang="en-US" smtClean="0"/>
-              <a:t>7/14/26</a:t>
+              <a:t>7/15/26</a:t>
             </a:fld>
             <a:endParaRPr lang="en-US"/>
           </a:p>
@@ -9113,7 +9114,7 @@
           <a:p>
             <a:fld id="{97860299-21CD-A94A-A7B0-44E787F8D42C}" type="datetime1">
               <a:rPr lang="en-US" smtClean="0"/>
-              <a:t>7/14/26</a:t>
+              <a:t>7/15/26</a:t>
             </a:fld>
             <a:endParaRPr lang="en-US"/>
           </a:p>
@@ -9398,7 +9399,7 @@
           <a:p>
             <a:fld id="{3DFD19CF-4E62-D246-BA61-7B528271315F}" type="datetime1">
               <a:rPr lang="en-US" smtClean="0"/>
-              <a:t>7/14/26</a:t>
+              <a:t>7/15/26</a:t>
             </a:fld>
             <a:endParaRPr lang="en-US"/>
           </a:p>
@@ -9521,7 +9522,7 @@
           <a:noFill/>
           <a:extLst>
             <a:ext uri="{909E8E84-426E-40dd-AFC4-6F175D3DCCD1}">
-              <a14:hiddenFill xmlns="" xmlns:a14="http://schemas.microsoft.com/office/drawing/2010/main">
+              <a14:hiddenFill xmlns:a14="http://schemas.microsoft.com/office/drawing/2010/main" xmlns="">
                 <a:solidFill>
                   <a:srgbClr val="FFFFFF"/>
                 </a:solidFill>
@@ -9595,7 +9596,7 @@
               </a:ln>
               <a:extLst>
                 <a:ext uri="{91240B29-F687-4f45-9708-019B960494DF}">
-                  <a14:hiddenLine xmlns="" xmlns:a14="http://schemas.microsoft.com/office/drawing/2010/main" w="9525">
+                  <a14:hiddenLine xmlns:a14="http://schemas.microsoft.com/office/drawing/2010/main" xmlns="" w="9525">
                     <a:solidFill>
                       <a:srgbClr val="000000"/>
                     </a:solidFill>
@@ -9685,7 +9686,7 @@
               </a:ln>
               <a:extLst>
                 <a:ext uri="{91240B29-F687-4f45-9708-019B960494DF}">
-                  <a14:hiddenLine xmlns="" xmlns:a14="http://schemas.microsoft.com/office/drawing/2010/main" w="9525">
+                  <a14:hiddenLine xmlns:a14="http://schemas.microsoft.com/office/drawing/2010/main" xmlns="" w="9525">
                     <a:solidFill>
                       <a:srgbClr val="000000"/>
                     </a:solidFill>
@@ -9775,7 +9776,7 @@
               </a:ln>
               <a:extLst>
                 <a:ext uri="{91240B29-F687-4f45-9708-019B960494DF}">
-                  <a14:hiddenLine xmlns="" xmlns:a14="http://schemas.microsoft.com/office/drawing/2010/main" w="9525">
+                  <a14:hiddenLine xmlns:a14="http://schemas.microsoft.com/office/drawing/2010/main" xmlns="" w="9525">
                     <a:solidFill>
                       <a:srgbClr val="000000"/>
                     </a:solidFill>
@@ -9837,7 +9838,7 @@
               </a:ln>
               <a:extLst>
                 <a:ext uri="{91240B29-F687-4f45-9708-019B960494DF}">
-                  <a14:hiddenLine xmlns="" xmlns:a14="http://schemas.microsoft.com/office/drawing/2010/main" w="9525">
+                  <a14:hiddenLine xmlns:a14="http://schemas.microsoft.com/office/drawing/2010/main" xmlns="" w="9525">
                     <a:solidFill>
                       <a:srgbClr val="000000"/>
                     </a:solidFill>
@@ -9927,7 +9928,7 @@
               </a:ln>
               <a:extLst>
                 <a:ext uri="{91240B29-F687-4f45-9708-019B960494DF}">
-                  <a14:hiddenLine xmlns="" xmlns:a14="http://schemas.microsoft.com/office/drawing/2010/main" w="9525">
+                  <a14:hiddenLine xmlns:a14="http://schemas.microsoft.com/office/drawing/2010/main" xmlns="" w="9525">
                     <a:solidFill>
                       <a:srgbClr val="000000"/>
                     </a:solidFill>
@@ -9989,7 +9990,7 @@
               </a:ln>
               <a:extLst>
                 <a:ext uri="{91240B29-F687-4f45-9708-019B960494DF}">
-                  <a14:hiddenLine xmlns="" xmlns:a14="http://schemas.microsoft.com/office/drawing/2010/main" w="9525">
+                  <a14:hiddenLine xmlns:a14="http://schemas.microsoft.com/office/drawing/2010/main" xmlns="" w="9525">
                     <a:solidFill>
                       <a:srgbClr val="000000"/>
                     </a:solidFill>
@@ -10051,7 +10052,7 @@
               </a:ln>
               <a:extLst>
                 <a:ext uri="{91240B29-F687-4f45-9708-019B960494DF}">
-                  <a14:hiddenLine xmlns="" xmlns:a14="http://schemas.microsoft.com/office/drawing/2010/main" w="9525">
+                  <a14:hiddenLine xmlns:a14="http://schemas.microsoft.com/office/drawing/2010/main" xmlns="" w="9525">
                     <a:solidFill>
                       <a:srgbClr val="000000"/>
                     </a:solidFill>
@@ -10141,7 +10142,7 @@
               </a:ln>
               <a:extLst>
                 <a:ext uri="{91240B29-F687-4f45-9708-019B960494DF}">
-                  <a14:hiddenLine xmlns="" xmlns:a14="http://schemas.microsoft.com/office/drawing/2010/main" w="9525">
+                  <a14:hiddenLine xmlns:a14="http://schemas.microsoft.com/office/drawing/2010/main" xmlns="" w="9525">
                     <a:solidFill>
                       <a:srgbClr val="000000"/>
                     </a:solidFill>
@@ -10231,7 +10232,7 @@
               </a:ln>
               <a:extLst>
                 <a:ext uri="{91240B29-F687-4f45-9708-019B960494DF}">
-                  <a14:hiddenLine xmlns="" xmlns:a14="http://schemas.microsoft.com/office/drawing/2010/main" w="9525">
+                  <a14:hiddenLine xmlns:a14="http://schemas.microsoft.com/office/drawing/2010/main" xmlns="" w="9525">
                     <a:solidFill>
                       <a:srgbClr val="000000"/>
                     </a:solidFill>
@@ -10293,7 +10294,7 @@
               </a:ln>
               <a:extLst>
                 <a:ext uri="{91240B29-F687-4f45-9708-019B960494DF}">
-                  <a14:hiddenLine xmlns="" xmlns:a14="http://schemas.microsoft.com/office/drawing/2010/main" w="9525">
+                  <a14:hiddenLine xmlns:a14="http://schemas.microsoft.com/office/drawing/2010/main" xmlns="" w="9525">
                     <a:solidFill>
                       <a:srgbClr val="000000"/>
                     </a:solidFill>
@@ -10403,7 +10404,7 @@
               </a:ln>
               <a:extLst>
                 <a:ext uri="{91240B29-F687-4f45-9708-019B960494DF}">
-                  <a14:hiddenLine xmlns="" xmlns:a14="http://schemas.microsoft.com/office/drawing/2010/main" w="9525">
+                  <a14:hiddenLine xmlns:a14="http://schemas.microsoft.com/office/drawing/2010/main" xmlns="" w="9525">
                     <a:solidFill>
                       <a:srgbClr val="000000"/>
                     </a:solidFill>
@@ -10487,7 +10488,7 @@
               </a:ln>
               <a:extLst>
                 <a:ext uri="{91240B29-F687-4f45-9708-019B960494DF}">
-                  <a14:hiddenLine xmlns="" xmlns:a14="http://schemas.microsoft.com/office/drawing/2010/main" w="9525">
+                  <a14:hiddenLine xmlns:a14="http://schemas.microsoft.com/office/drawing/2010/main" xmlns="" w="9525">
                     <a:solidFill>
                       <a:srgbClr val="000000"/>
                     </a:solidFill>
@@ -10549,7 +10550,7 @@
               </a:ln>
               <a:extLst>
                 <a:ext uri="{91240B29-F687-4f45-9708-019B960494DF}">
-                  <a14:hiddenLine xmlns="" xmlns:a14="http://schemas.microsoft.com/office/drawing/2010/main" w="9525">
+                  <a14:hiddenLine xmlns:a14="http://schemas.microsoft.com/office/drawing/2010/main" xmlns="" w="9525">
                     <a:solidFill>
                       <a:srgbClr val="000000"/>
                     </a:solidFill>
@@ -10611,7 +10612,7 @@
               </a:ln>
               <a:extLst>
                 <a:ext uri="{91240B29-F687-4f45-9708-019B960494DF}">
-                  <a14:hiddenLine xmlns="" xmlns:a14="http://schemas.microsoft.com/office/drawing/2010/main" w="9525">
+                  <a14:hiddenLine xmlns:a14="http://schemas.microsoft.com/office/drawing/2010/main" xmlns="" w="9525">
                     <a:solidFill>
                       <a:srgbClr val="000000"/>
                     </a:solidFill>
@@ -10701,7 +10702,7 @@
               </a:ln>
               <a:extLst>
                 <a:ext uri="{91240B29-F687-4f45-9708-019B960494DF}">
-                  <a14:hiddenLine xmlns="" xmlns:a14="http://schemas.microsoft.com/office/drawing/2010/main" w="9525">
+                  <a14:hiddenLine xmlns:a14="http://schemas.microsoft.com/office/drawing/2010/main" xmlns="" w="9525">
                     <a:solidFill>
                       <a:srgbClr val="000000"/>
                     </a:solidFill>
@@ -10735,7 +10736,7 @@
               </a:ln>
               <a:extLst>
                 <a:ext uri="{91240B29-F687-4f45-9708-019B960494DF}">
-                  <a14:hiddenLine xmlns="" xmlns:a14="http://schemas.microsoft.com/office/drawing/2010/main" w="9525">
+                  <a14:hiddenLine xmlns:a14="http://schemas.microsoft.com/office/drawing/2010/main" xmlns="" w="9525">
                     <a:solidFill>
                       <a:srgbClr val="000000"/>
                     </a:solidFill>
@@ -10800,7 +10801,7 @@
               </a:ln>
               <a:extLst>
                 <a:ext uri="{91240B29-F687-4f45-9708-019B960494DF}">
-                  <a14:hiddenLine xmlns="" xmlns:a14="http://schemas.microsoft.com/office/drawing/2010/main" w="9525">
+                  <a14:hiddenLine xmlns:a14="http://schemas.microsoft.com/office/drawing/2010/main" xmlns="" w="9525">
                     <a:solidFill>
                       <a:srgbClr val="000000"/>
                     </a:solidFill>
@@ -10890,7 +10891,7 @@
               </a:ln>
               <a:extLst>
                 <a:ext uri="{91240B29-F687-4f45-9708-019B960494DF}">
-                  <a14:hiddenLine xmlns="" xmlns:a14="http://schemas.microsoft.com/office/drawing/2010/main" w="9525">
+                  <a14:hiddenLine xmlns:a14="http://schemas.microsoft.com/office/drawing/2010/main" xmlns="" w="9525">
                     <a:solidFill>
                       <a:srgbClr val="000000"/>
                     </a:solidFill>
@@ -10952,7 +10953,7 @@
               </a:ln>
               <a:extLst>
                 <a:ext uri="{91240B29-F687-4f45-9708-019B960494DF}">
-                  <a14:hiddenLine xmlns="" xmlns:a14="http://schemas.microsoft.com/office/drawing/2010/main" w="9525">
+                  <a14:hiddenLine xmlns:a14="http://schemas.microsoft.com/office/drawing/2010/main" xmlns="" w="9525">
                     <a:solidFill>
                       <a:srgbClr val="000000"/>
                     </a:solidFill>
@@ -11042,7 +11043,7 @@
               </a:ln>
               <a:extLst>
                 <a:ext uri="{91240B29-F687-4f45-9708-019B960494DF}">
-                  <a14:hiddenLine xmlns="" xmlns:a14="http://schemas.microsoft.com/office/drawing/2010/main" w="9525">
+                  <a14:hiddenLine xmlns:a14="http://schemas.microsoft.com/office/drawing/2010/main" xmlns="" w="9525">
                     <a:solidFill>
                       <a:srgbClr val="000000"/>
                     </a:solidFill>
@@ -11107,7 +11108,7 @@
               </a:ln>
               <a:extLst>
                 <a:ext uri="{91240B29-F687-4f45-9708-019B960494DF}">
-                  <a14:hiddenLine xmlns="" xmlns:a14="http://schemas.microsoft.com/office/drawing/2010/main" w="9525">
+                  <a14:hiddenLine xmlns:a14="http://schemas.microsoft.com/office/drawing/2010/main" xmlns="" w="9525">
                     <a:solidFill>
                       <a:srgbClr val="000000"/>
                     </a:solidFill>
@@ -11169,7 +11170,7 @@
               </a:ln>
               <a:extLst>
                 <a:ext uri="{91240B29-F687-4f45-9708-019B960494DF}">
-                  <a14:hiddenLine xmlns="" xmlns:a14="http://schemas.microsoft.com/office/drawing/2010/main" w="9525">
+                  <a14:hiddenLine xmlns:a14="http://schemas.microsoft.com/office/drawing/2010/main" xmlns="" w="9525">
                     <a:solidFill>
                       <a:srgbClr val="000000"/>
                     </a:solidFill>
@@ -11259,7 +11260,7 @@
               </a:ln>
               <a:extLst>
                 <a:ext uri="{91240B29-F687-4f45-9708-019B960494DF}">
-                  <a14:hiddenLine xmlns="" xmlns:a14="http://schemas.microsoft.com/office/drawing/2010/main" w="9525">
+                  <a14:hiddenLine xmlns:a14="http://schemas.microsoft.com/office/drawing/2010/main" xmlns="" w="9525">
                     <a:solidFill>
                       <a:srgbClr val="000000"/>
                     </a:solidFill>
@@ -11349,7 +11350,7 @@
               </a:ln>
               <a:extLst>
                 <a:ext uri="{91240B29-F687-4f45-9708-019B960494DF}">
-                  <a14:hiddenLine xmlns="" xmlns:a14="http://schemas.microsoft.com/office/drawing/2010/main" w="9525">
+                  <a14:hiddenLine xmlns:a14="http://schemas.microsoft.com/office/drawing/2010/main" xmlns="" w="9525">
                     <a:solidFill>
                       <a:srgbClr val="000000"/>
                     </a:solidFill>
@@ -11414,7 +11415,7 @@
               </a:ln>
               <a:extLst>
                 <a:ext uri="{91240B29-F687-4f45-9708-019B960494DF}">
-                  <a14:hiddenLine xmlns="" xmlns:a14="http://schemas.microsoft.com/office/drawing/2010/main" w="9525">
+                  <a14:hiddenLine xmlns:a14="http://schemas.microsoft.com/office/drawing/2010/main" xmlns="" w="9525">
                     <a:solidFill>
                       <a:srgbClr val="000000"/>
                     </a:solidFill>
@@ -11534,7 +11535,7 @@
               </a:ln>
               <a:extLst>
                 <a:ext uri="{91240B29-F687-4f45-9708-019B960494DF}">
-                  <a14:hiddenLine xmlns="" xmlns:a14="http://schemas.microsoft.com/office/drawing/2010/main" w="9525">
+                  <a14:hiddenLine xmlns:a14="http://schemas.microsoft.com/office/drawing/2010/main" xmlns="" w="9525">
                     <a:solidFill>
                       <a:srgbClr val="000000"/>
                     </a:solidFill>
@@ -11615,7 +11616,7 @@
               </a:ln>
               <a:extLst>
                 <a:ext uri="{91240B29-F687-4f45-9708-019B960494DF}">
-                  <a14:hiddenLine xmlns="" xmlns:a14="http://schemas.microsoft.com/office/drawing/2010/main" w="9525">
+                  <a14:hiddenLine xmlns:a14="http://schemas.microsoft.com/office/drawing/2010/main" xmlns="" w="9525">
                     <a:solidFill>
                       <a:srgbClr val="000000"/>
                     </a:solidFill>
@@ -11730,7 +11731,7 @@
               </a:ln>
               <a:extLst>
                 <a:ext uri="{91240B29-F687-4f45-9708-019B960494DF}">
-                  <a14:hiddenLine xmlns="" xmlns:a14="http://schemas.microsoft.com/office/drawing/2010/main" w="9525">
+                  <a14:hiddenLine xmlns:a14="http://schemas.microsoft.com/office/drawing/2010/main" xmlns="" w="9525">
                     <a:solidFill>
                       <a:srgbClr val="000000"/>
                     </a:solidFill>
@@ -11820,7 +11821,7 @@
               </a:ln>
               <a:extLst>
                 <a:ext uri="{91240B29-F687-4f45-9708-019B960494DF}">
-                  <a14:hiddenLine xmlns="" xmlns:a14="http://schemas.microsoft.com/office/drawing/2010/main" w="9525">
+                  <a14:hiddenLine xmlns:a14="http://schemas.microsoft.com/office/drawing/2010/main" xmlns="" w="9525">
                     <a:solidFill>
                       <a:srgbClr val="000000"/>
                     </a:solidFill>
@@ -11885,7 +11886,7 @@
               </a:ln>
               <a:extLst>
                 <a:ext uri="{91240B29-F687-4f45-9708-019B960494DF}">
-                  <a14:hiddenLine xmlns="" xmlns:a14="http://schemas.microsoft.com/office/drawing/2010/main" w="9525">
+                  <a14:hiddenLine xmlns:a14="http://schemas.microsoft.com/office/drawing/2010/main" xmlns="" w="9525">
                     <a:solidFill>
                       <a:srgbClr val="000000"/>
                     </a:solidFill>
@@ -11975,7 +11976,7 @@
               </a:ln>
               <a:extLst>
                 <a:ext uri="{91240B29-F687-4f45-9708-019B960494DF}">
-                  <a14:hiddenLine xmlns="" xmlns:a14="http://schemas.microsoft.com/office/drawing/2010/main" w="9525">
+                  <a14:hiddenLine xmlns:a14="http://schemas.microsoft.com/office/drawing/2010/main" xmlns="" w="9525">
                     <a:solidFill>
                       <a:srgbClr val="000000"/>
                     </a:solidFill>
@@ -12043,7 +12044,7 @@
               </a:ln>
               <a:extLst>
                 <a:ext uri="{91240B29-F687-4f45-9708-019B960494DF}">
-                  <a14:hiddenLine xmlns="" xmlns:a14="http://schemas.microsoft.com/office/drawing/2010/main" w="9525">
+                  <a14:hiddenLine xmlns:a14="http://schemas.microsoft.com/office/drawing/2010/main" xmlns="" w="9525">
                     <a:solidFill>
                       <a:srgbClr val="000000"/>
                     </a:solidFill>
@@ -12133,7 +12134,7 @@
               </a:ln>
               <a:extLst>
                 <a:ext uri="{91240B29-F687-4f45-9708-019B960494DF}">
-                  <a14:hiddenLine xmlns="" xmlns:a14="http://schemas.microsoft.com/office/drawing/2010/main" w="9525">
+                  <a14:hiddenLine xmlns:a14="http://schemas.microsoft.com/office/drawing/2010/main" xmlns="" w="9525">
                     <a:solidFill>
                       <a:srgbClr val="000000"/>
                     </a:solidFill>
@@ -12201,7 +12202,7 @@
               </a:ln>
               <a:extLst>
                 <a:ext uri="{91240B29-F687-4f45-9708-019B960494DF}">
-                  <a14:hiddenLine xmlns="" xmlns:a14="http://schemas.microsoft.com/office/drawing/2010/main" w="9525">
+                  <a14:hiddenLine xmlns:a14="http://schemas.microsoft.com/office/drawing/2010/main" xmlns="" w="9525">
                     <a:solidFill>
                       <a:srgbClr val="000000"/>
                     </a:solidFill>
@@ -12291,7 +12292,7 @@
               </a:ln>
               <a:extLst>
                 <a:ext uri="{91240B29-F687-4f45-9708-019B960494DF}">
-                  <a14:hiddenLine xmlns="" xmlns:a14="http://schemas.microsoft.com/office/drawing/2010/main" w="9525">
+                  <a14:hiddenLine xmlns:a14="http://schemas.microsoft.com/office/drawing/2010/main" xmlns="" w="9525">
                     <a:solidFill>
                       <a:srgbClr val="000000"/>
                     </a:solidFill>
@@ -12325,7 +12326,7 @@
               </a:ln>
               <a:extLst>
                 <a:ext uri="{91240B29-F687-4f45-9708-019B960494DF}">
-                  <a14:hiddenLine xmlns="" xmlns:a14="http://schemas.microsoft.com/office/drawing/2010/main" w="9525">
+                  <a14:hiddenLine xmlns:a14="http://schemas.microsoft.com/office/drawing/2010/main" xmlns="" w="9525">
                     <a:solidFill>
                       <a:srgbClr val="000000"/>
                     </a:solidFill>
@@ -12465,7 +12466,7 @@
           <a:p>
             <a:fld id="{92FF8978-FE14-CC4A-93A6-934EB06543C0}" type="datetime1">
               <a:rPr lang="en-US" smtClean="0"/>
-              <a:t>7/14/26</a:t>
+              <a:t>7/15/26</a:t>
             </a:fld>
             <a:endParaRPr lang="en-US"/>
           </a:p>
@@ -13133,6 +13134,183 @@
 </file>
 
 <file path=ppt/slides/slide3.xml><?xml version="1.0" encoding="utf-8"?>
+<p:sld xmlns:a="http://schemas.openxmlformats.org/drawingml/2006/main" xmlns:r="http://schemas.openxmlformats.org/officeDocument/2006/relationships" xmlns:p="http://schemas.openxmlformats.org/presentationml/2006/main">
+  <p:cSld>
+    <p:spTree>
+      <p:nvGrpSpPr>
+        <p:cNvPr id="1" name="">
+          <a:extLst>
+            <a:ext uri="{FF2B5EF4-FFF2-40B4-BE49-F238E27FC236}">
+              <a16:creationId xmlns:a16="http://schemas.microsoft.com/office/drawing/2014/main" id="{FCA32411-328E-66E8-E6F4-EF539979CE9D}"/>
+            </a:ext>
+          </a:extLst>
+        </p:cNvPr>
+        <p:cNvGrpSpPr/>
+        <p:nvPr/>
+      </p:nvGrpSpPr>
+      <p:grpSpPr>
+        <a:xfrm>
+          <a:off x="0" y="0"/>
+          <a:ext cx="0" cy="0"/>
+          <a:chOff x="0" y="0"/>
+          <a:chExt cx="0" cy="0"/>
+        </a:xfrm>
+      </p:grpSpPr>
+      <p:sp>
+        <p:nvSpPr>
+          <p:cNvPr id="6146" name="Rectangle 2">
+            <a:extLst>
+              <a:ext uri="{FF2B5EF4-FFF2-40B4-BE49-F238E27FC236}">
+                <a16:creationId xmlns:a16="http://schemas.microsoft.com/office/drawing/2014/main" id="{D6CDF740-7CD2-4A8A-F4A5-5B9BBC68854B}"/>
+              </a:ext>
+            </a:extLst>
+          </p:cNvPr>
+          <p:cNvSpPr>
+            <a:spLocks noGrp="1" noChangeArrowheads="1"/>
+          </p:cNvSpPr>
+          <p:nvPr>
+            <p:ph type="title"/>
+            <p:custDataLst>
+              <p:tags r:id="rId1"/>
+            </p:custDataLst>
+          </p:nvPr>
+        </p:nvSpPr>
+        <p:spPr>
+          <a:xfrm>
+            <a:off x="1141413" y="284084"/>
+            <a:ext cx="9905998" cy="620791"/>
+          </a:xfrm>
+        </p:spPr>
+        <p:txBody>
+          <a:bodyPr/>
+          <a:lstStyle/>
+          <a:p>
+            <a:pPr algn="ctr"/>
+            <a:r>
+              <a:rPr lang="en-US" dirty="0"/>
+              <a:t>Week 1: Wednesday</a:t>
+            </a:r>
+          </a:p>
+        </p:txBody>
+      </p:sp>
+      <p:sp>
+        <p:nvSpPr>
+          <p:cNvPr id="6147" name="Rectangle 3">
+            <a:extLst>
+              <a:ext uri="{FF2B5EF4-FFF2-40B4-BE49-F238E27FC236}">
+                <a16:creationId xmlns:a16="http://schemas.microsoft.com/office/drawing/2014/main" id="{79392D12-A499-BDA8-BD1E-87BBE9A531AD}"/>
+              </a:ext>
+            </a:extLst>
+          </p:cNvPr>
+          <p:cNvSpPr>
+            <a:spLocks noGrp="1" noChangeArrowheads="1"/>
+          </p:cNvSpPr>
+          <p:nvPr>
+            <p:ph idx="1"/>
+            <p:custDataLst>
+              <p:tags r:id="rId2"/>
+            </p:custDataLst>
+          </p:nvPr>
+        </p:nvSpPr>
+        <p:spPr>
+          <a:xfrm>
+            <a:off x="1294151" y="1098549"/>
+            <a:ext cx="9600522" cy="5149850"/>
+          </a:xfrm>
+        </p:spPr>
+        <p:txBody>
+          <a:bodyPr>
+            <a:normAutofit/>
+          </a:bodyPr>
+          <a:lstStyle/>
+          <a:p>
+            <a:r>
+              <a:rPr lang="en-US" dirty="0">
+                <a:latin typeface="Arial" panose="020B0604020202020204" pitchFamily="34" charset="0"/>
+                <a:cs typeface="Arial" panose="020B0604020202020204" pitchFamily="34" charset="0"/>
+              </a:rPr>
+              <a:t>First homework is due Tonight! (Wednesday)</a:t>
+            </a:r>
+          </a:p>
+          <a:p>
+            <a:pPr lvl="1"/>
+            <a:r>
+              <a:rPr lang="en-US" dirty="0">
+                <a:latin typeface="Arial" panose="020B0604020202020204" pitchFamily="34" charset="0"/>
+                <a:cs typeface="Arial" panose="020B0604020202020204" pitchFamily="34" charset="0"/>
+              </a:rPr>
+              <a:t>3 day extension if you really need it but you really should try not to use it for this one.</a:t>
+            </a:r>
+          </a:p>
+          <a:p>
+            <a:r>
+              <a:rPr lang="en-US" dirty="0">
+                <a:latin typeface="Arial" panose="020B0604020202020204" pitchFamily="34" charset="0"/>
+                <a:cs typeface="Arial" panose="020B0604020202020204" pitchFamily="34" charset="0"/>
+              </a:rPr>
+              <a:t>Please remember that I am asking for NO laptop / phones!</a:t>
+            </a:r>
+          </a:p>
+          <a:p>
+            <a:pPr lvl="1"/>
+            <a:r>
+              <a:rPr lang="en-US" dirty="0">
+                <a:latin typeface="Arial" panose="020B0604020202020204" pitchFamily="34" charset="0"/>
+                <a:cs typeface="Arial" panose="020B0604020202020204" pitchFamily="34" charset="0"/>
+              </a:rPr>
+              <a:t>This makes the learning environment better for everybody. I appreciate it!</a:t>
+            </a:r>
+          </a:p>
+          <a:p>
+            <a:r>
+              <a:rPr lang="en-US" dirty="0">
+                <a:latin typeface="Arial" panose="020B0604020202020204" pitchFamily="34" charset="0"/>
+                <a:cs typeface="Arial" panose="020B0604020202020204" pitchFamily="34" charset="0"/>
+              </a:rPr>
+              <a:t>Attendance continues today as usual.</a:t>
+            </a:r>
+          </a:p>
+          <a:p>
+            <a:r>
+              <a:rPr lang="en-US" dirty="0">
+                <a:latin typeface="Arial" panose="020B0604020202020204" pitchFamily="34" charset="0"/>
+                <a:cs typeface="Arial" panose="020B0604020202020204" pitchFamily="34" charset="0"/>
+              </a:rPr>
+              <a:t>We begin module 1 today (the real class begins).</a:t>
+            </a:r>
+          </a:p>
+          <a:p>
+            <a:pPr lvl="1"/>
+            <a:r>
+              <a:rPr lang="en-US" dirty="0">
+                <a:latin typeface="Arial" panose="020B0604020202020204" pitchFamily="34" charset="0"/>
+                <a:cs typeface="Arial" panose="020B0604020202020204" pitchFamily="34" charset="0"/>
+              </a:rPr>
+              <a:t>It will likely take us at least the rest of this week to get through.</a:t>
+            </a:r>
+          </a:p>
+          <a:p>
+            <a:endParaRPr lang="en-US" dirty="0">
+              <a:latin typeface="Arial" panose="020B0604020202020204" pitchFamily="34" charset="0"/>
+              <a:cs typeface="Arial" panose="020B0604020202020204" pitchFamily="34" charset="0"/>
+            </a:endParaRPr>
+          </a:p>
+        </p:txBody>
+      </p:sp>
+    </p:spTree>
+    <p:extLst>
+      <p:ext uri="{BB962C8B-B14F-4D97-AF65-F5344CB8AC3E}">
+        <p14:creationId xmlns:p14="http://schemas.microsoft.com/office/powerpoint/2010/main" val="3784255301"/>
+      </p:ext>
+    </p:extLst>
+  </p:cSld>
+  <p:clrMapOvr>
+    <a:masterClrMapping/>
+  </p:clrMapOvr>
+</p:sld>
+</file>
+
+<file path=ppt/slides/slide4.xml><?xml version="1.0" encoding="utf-8"?>
 <p:sld xmlns:a="http://schemas.openxmlformats.org/drawingml/2006/main" xmlns:r="http://schemas.openxmlformats.org/officeDocument/2006/relationships" xmlns:p="http://schemas.openxmlformats.org/presentationml/2006/main">
   <p:cSld>
     <p:spTree>
@@ -15042,6 +15220,18 @@
 </p:tagLst>
 </file>
 
+<file path=ppt/tags/tag8.xml><?xml version="1.0" encoding="utf-8"?>
+<p:tagLst xmlns:a="http://schemas.openxmlformats.org/drawingml/2006/main" xmlns:r="http://schemas.openxmlformats.org/officeDocument/2006/relationships" xmlns:p="http://schemas.openxmlformats.org/presentationml/2006/main">
+  <p:tag name="_INSTRUCTOR VIEW19C14C36-AC8E-43BC-9DB6-C2AAF774C7DC|PANE__TAG" val="_"/>
+</p:tagLst>
+</file>
+
+<file path=ppt/tags/tag9.xml><?xml version="1.0" encoding="utf-8"?>
+<p:tagLst xmlns:a="http://schemas.openxmlformats.org/drawingml/2006/main" xmlns:r="http://schemas.openxmlformats.org/officeDocument/2006/relationships" xmlns:p="http://schemas.openxmlformats.org/presentationml/2006/main">
+  <p:tag name="_INSTRUCTOR VIEW19C14C36-AC8E-43BC-9DB6-C2AAF774C7DC|PANE__TAG" val="_"/>
+</p:tagLst>
+</file>
+
 <file path=ppt/theme/theme1.xml><?xml version="1.0" encoding="utf-8"?>
 <a:theme xmlns:a="http://schemas.openxmlformats.org/drawingml/2006/main" name="Circuit">
   <a:themeElements>

</xml_diff>

<commit_message>
announcements, adding summer exam
</commit_message>
<xml_diff>
--- a/slides/00-DailyAnnouncements.pptx
+++ b/slides/00-DailyAnnouncements.pptx
@@ -5,7 +5,7 @@
     <p:sldMasterId id="2147484006" r:id="rId1"/>
   </p:sldMasterIdLst>
   <p:notesMasterIdLst>
-    <p:notesMasterId r:id="rId16"/>
+    <p:notesMasterId r:id="rId17"/>
   </p:notesMasterIdLst>
   <p:sldIdLst>
     <p:sldId id="256" r:id="rId2"/>
@@ -21,7 +21,8 @@
     <p:sldId id="524" r:id="rId12"/>
     <p:sldId id="525" r:id="rId13"/>
     <p:sldId id="526" r:id="rId14"/>
-    <p:sldId id="515" r:id="rId15"/>
+    <p:sldId id="527" r:id="rId15"/>
+    <p:sldId id="515" r:id="rId16"/>
   </p:sldIdLst>
   <p:sldSz cx="12192000" cy="6858000"/>
   <p:notesSz cx="6858000" cy="9144000"/>
@@ -210,7 +211,7 @@
           <a:p>
             <a:fld id="{C5B45307-6ED4-B142-BD64-10F739779302}" type="datetimeFigureOut">
               <a:rPr lang="en-US" smtClean="0"/>
-              <a:t>7/30/26</a:t>
+              <a:t>8/3/26</a:t>
             </a:fld>
             <a:endParaRPr lang="en-US"/>
           </a:p>
@@ -618,7 +619,7 @@
           <a:noFill/>
           <a:extLst>
             <a:ext uri="{909E8E84-426E-40dd-AFC4-6F175D3DCCD1}">
-              <a14:hiddenFill xmlns:a14="http://schemas.microsoft.com/office/drawing/2010/main" xmlns="">
+              <a14:hiddenFill xmlns="" xmlns:a14="http://schemas.microsoft.com/office/drawing/2010/main">
                 <a:solidFill>
                   <a:srgbClr val="FFFFFF"/>
                 </a:solidFill>
@@ -677,7 +678,7 @@
             </a:ln>
             <a:extLst>
               <a:ext uri="{91240B29-F687-4f45-9708-019B960494DF}">
-                <a14:hiddenLine xmlns:a14="http://schemas.microsoft.com/office/drawing/2010/main" xmlns="" w="9525">
+                <a14:hiddenLine xmlns="" xmlns:a14="http://schemas.microsoft.com/office/drawing/2010/main" w="9525">
                   <a:solidFill>
                     <a:srgbClr val="000000"/>
                   </a:solidFill>
@@ -767,7 +768,7 @@
             </a:ln>
             <a:extLst>
               <a:ext uri="{91240B29-F687-4f45-9708-019B960494DF}">
-                <a14:hiddenLine xmlns:a14="http://schemas.microsoft.com/office/drawing/2010/main" xmlns="" w="9525">
+                <a14:hiddenLine xmlns="" xmlns:a14="http://schemas.microsoft.com/office/drawing/2010/main" w="9525">
                   <a:solidFill>
                     <a:srgbClr val="000000"/>
                   </a:solidFill>
@@ -857,7 +858,7 @@
             </a:ln>
             <a:extLst>
               <a:ext uri="{91240B29-F687-4f45-9708-019B960494DF}">
-                <a14:hiddenLine xmlns:a14="http://schemas.microsoft.com/office/drawing/2010/main" xmlns="" w="9525">
+                <a14:hiddenLine xmlns="" xmlns:a14="http://schemas.microsoft.com/office/drawing/2010/main" w="9525">
                   <a:solidFill>
                     <a:srgbClr val="000000"/>
                   </a:solidFill>
@@ -891,7 +892,7 @@
             </a:ln>
             <a:extLst>
               <a:ext uri="{91240B29-F687-4f45-9708-019B960494DF}">
-                <a14:hiddenLine xmlns:a14="http://schemas.microsoft.com/office/drawing/2010/main" xmlns="" w="9525">
+                <a14:hiddenLine xmlns="" xmlns:a14="http://schemas.microsoft.com/office/drawing/2010/main" w="9525">
                   <a:solidFill>
                     <a:srgbClr val="000000"/>
                   </a:solidFill>
@@ -981,7 +982,7 @@
             </a:ln>
             <a:extLst>
               <a:ext uri="{91240B29-F687-4f45-9708-019B960494DF}">
-                <a14:hiddenLine xmlns:a14="http://schemas.microsoft.com/office/drawing/2010/main" xmlns="" w="9525">
+                <a14:hiddenLine xmlns="" xmlns:a14="http://schemas.microsoft.com/office/drawing/2010/main" w="9525">
                   <a:solidFill>
                     <a:srgbClr val="000000"/>
                   </a:solidFill>
@@ -1043,7 +1044,7 @@
             </a:ln>
             <a:extLst>
               <a:ext uri="{91240B29-F687-4f45-9708-019B960494DF}">
-                <a14:hiddenLine xmlns:a14="http://schemas.microsoft.com/office/drawing/2010/main" xmlns="" w="9525">
+                <a14:hiddenLine xmlns="" xmlns:a14="http://schemas.microsoft.com/office/drawing/2010/main" w="9525">
                   <a:solidFill>
                     <a:srgbClr val="000000"/>
                   </a:solidFill>
@@ -1105,7 +1106,7 @@
             </a:ln>
             <a:extLst>
               <a:ext uri="{91240B29-F687-4f45-9708-019B960494DF}">
-                <a14:hiddenLine xmlns:a14="http://schemas.microsoft.com/office/drawing/2010/main" xmlns="" w="9525">
+                <a14:hiddenLine xmlns="" xmlns:a14="http://schemas.microsoft.com/office/drawing/2010/main" w="9525">
                   <a:solidFill>
                     <a:srgbClr val="000000"/>
                   </a:solidFill>
@@ -1195,7 +1196,7 @@
             </a:ln>
             <a:extLst>
               <a:ext uri="{91240B29-F687-4f45-9708-019B960494DF}">
-                <a14:hiddenLine xmlns:a14="http://schemas.microsoft.com/office/drawing/2010/main" xmlns="" w="9525">
+                <a14:hiddenLine xmlns="" xmlns:a14="http://schemas.microsoft.com/office/drawing/2010/main" w="9525">
                   <a:solidFill>
                     <a:srgbClr val="000000"/>
                   </a:solidFill>
@@ -1257,7 +1258,7 @@
             </a:ln>
             <a:extLst>
               <a:ext uri="{91240B29-F687-4f45-9708-019B960494DF}">
-                <a14:hiddenLine xmlns:a14="http://schemas.microsoft.com/office/drawing/2010/main" xmlns="" w="9525">
+                <a14:hiddenLine xmlns="" xmlns:a14="http://schemas.microsoft.com/office/drawing/2010/main" w="9525">
                   <a:solidFill>
                     <a:srgbClr val="000000"/>
                   </a:solidFill>
@@ -1319,7 +1320,7 @@
             </a:ln>
             <a:extLst>
               <a:ext uri="{91240B29-F687-4f45-9708-019B960494DF}">
-                <a14:hiddenLine xmlns:a14="http://schemas.microsoft.com/office/drawing/2010/main" xmlns="" w="9525">
+                <a14:hiddenLine xmlns="" xmlns:a14="http://schemas.microsoft.com/office/drawing/2010/main" w="9525">
                   <a:solidFill>
                     <a:srgbClr val="000000"/>
                   </a:solidFill>
@@ -1409,7 +1410,7 @@
             </a:ln>
             <a:extLst>
               <a:ext uri="{91240B29-F687-4f45-9708-019B960494DF}">
-                <a14:hiddenLine xmlns:a14="http://schemas.microsoft.com/office/drawing/2010/main" xmlns="" w="9525">
+                <a14:hiddenLine xmlns="" xmlns:a14="http://schemas.microsoft.com/office/drawing/2010/main" w="9525">
                   <a:solidFill>
                     <a:srgbClr val="000000"/>
                   </a:solidFill>
@@ -1499,7 +1500,7 @@
             </a:ln>
             <a:extLst>
               <a:ext uri="{91240B29-F687-4f45-9708-019B960494DF}">
-                <a14:hiddenLine xmlns:a14="http://schemas.microsoft.com/office/drawing/2010/main" xmlns="" w="9525">
+                <a14:hiddenLine xmlns="" xmlns:a14="http://schemas.microsoft.com/office/drawing/2010/main" w="9525">
                   <a:solidFill>
                     <a:srgbClr val="000000"/>
                   </a:solidFill>
@@ -1561,7 +1562,7 @@
             </a:ln>
             <a:extLst>
               <a:ext uri="{91240B29-F687-4f45-9708-019B960494DF}">
-                <a14:hiddenLine xmlns:a14="http://schemas.microsoft.com/office/drawing/2010/main" xmlns="" w="9525">
+                <a14:hiddenLine xmlns="" xmlns:a14="http://schemas.microsoft.com/office/drawing/2010/main" w="9525">
                   <a:solidFill>
                     <a:srgbClr val="000000"/>
                   </a:solidFill>
@@ -1671,7 +1672,7 @@
             </a:ln>
             <a:extLst>
               <a:ext uri="{91240B29-F687-4f45-9708-019B960494DF}">
-                <a14:hiddenLine xmlns:a14="http://schemas.microsoft.com/office/drawing/2010/main" xmlns="" w="9525">
+                <a14:hiddenLine xmlns="" xmlns:a14="http://schemas.microsoft.com/office/drawing/2010/main" w="9525">
                   <a:solidFill>
                     <a:srgbClr val="000000"/>
                   </a:solidFill>
@@ -1733,7 +1734,7 @@
             </a:ln>
             <a:extLst>
               <a:ext uri="{91240B29-F687-4f45-9708-019B960494DF}">
-                <a14:hiddenLine xmlns:a14="http://schemas.microsoft.com/office/drawing/2010/main" xmlns="" w="9525">
+                <a14:hiddenLine xmlns="" xmlns:a14="http://schemas.microsoft.com/office/drawing/2010/main" w="9525">
                   <a:solidFill>
                     <a:srgbClr val="000000"/>
                   </a:solidFill>
@@ -1823,7 +1824,7 @@
             </a:ln>
             <a:extLst>
               <a:ext uri="{91240B29-F687-4f45-9708-019B960494DF}">
-                <a14:hiddenLine xmlns:a14="http://schemas.microsoft.com/office/drawing/2010/main" xmlns="" w="9525">
+                <a14:hiddenLine xmlns="" xmlns:a14="http://schemas.microsoft.com/office/drawing/2010/main" w="9525">
                   <a:solidFill>
                     <a:srgbClr val="000000"/>
                   </a:solidFill>
@@ -1913,7 +1914,7 @@
             </a:ln>
             <a:extLst>
               <a:ext uri="{91240B29-F687-4f45-9708-019B960494DF}">
-                <a14:hiddenLine xmlns:a14="http://schemas.microsoft.com/office/drawing/2010/main" xmlns="" w="9525">
+                <a14:hiddenLine xmlns="" xmlns:a14="http://schemas.microsoft.com/office/drawing/2010/main" w="9525">
                   <a:solidFill>
                     <a:srgbClr val="000000"/>
                   </a:solidFill>
@@ -1975,7 +1976,7 @@
             </a:ln>
             <a:extLst>
               <a:ext uri="{91240B29-F687-4f45-9708-019B960494DF}">
-                <a14:hiddenLine xmlns:a14="http://schemas.microsoft.com/office/drawing/2010/main" xmlns="" w="9525">
+                <a14:hiddenLine xmlns="" xmlns:a14="http://schemas.microsoft.com/office/drawing/2010/main" w="9525">
                   <a:solidFill>
                     <a:srgbClr val="000000"/>
                   </a:solidFill>
@@ -2065,7 +2066,7 @@
             </a:ln>
             <a:extLst>
               <a:ext uri="{91240B29-F687-4f45-9708-019B960494DF}">
-                <a14:hiddenLine xmlns:a14="http://schemas.microsoft.com/office/drawing/2010/main" xmlns="" w="9525">
+                <a14:hiddenLine xmlns="" xmlns:a14="http://schemas.microsoft.com/office/drawing/2010/main" w="9525">
                   <a:solidFill>
                     <a:srgbClr val="000000"/>
                   </a:solidFill>
@@ -2155,7 +2156,7 @@
             </a:ln>
             <a:extLst>
               <a:ext uri="{91240B29-F687-4f45-9708-019B960494DF}">
-                <a14:hiddenLine xmlns:a14="http://schemas.microsoft.com/office/drawing/2010/main" xmlns="" w="9525">
+                <a14:hiddenLine xmlns="" xmlns:a14="http://schemas.microsoft.com/office/drawing/2010/main" w="9525">
                   <a:solidFill>
                     <a:srgbClr val="000000"/>
                   </a:solidFill>
@@ -2211,7 +2212,7 @@
             </a:ln>
             <a:extLst>
               <a:ext uri="{91240B29-F687-4f45-9708-019B960494DF}">
-                <a14:hiddenLine xmlns:a14="http://schemas.microsoft.com/office/drawing/2010/main" xmlns="" w="9525">
+                <a14:hiddenLine xmlns="" xmlns:a14="http://schemas.microsoft.com/office/drawing/2010/main" w="9525">
                   <a:solidFill>
                     <a:srgbClr val="000000"/>
                   </a:solidFill>
@@ -2301,7 +2302,7 @@
             </a:ln>
             <a:extLst>
               <a:ext uri="{91240B29-F687-4f45-9708-019B960494DF}">
-                <a14:hiddenLine xmlns:a14="http://schemas.microsoft.com/office/drawing/2010/main" xmlns="" w="9525">
+                <a14:hiddenLine xmlns="" xmlns:a14="http://schemas.microsoft.com/office/drawing/2010/main" w="9525">
                   <a:solidFill>
                     <a:srgbClr val="000000"/>
                   </a:solidFill>
@@ -2357,7 +2358,7 @@
             </a:ln>
             <a:extLst>
               <a:ext uri="{91240B29-F687-4f45-9708-019B960494DF}">
-                <a14:hiddenLine xmlns:a14="http://schemas.microsoft.com/office/drawing/2010/main" xmlns="" w="9525">
+                <a14:hiddenLine xmlns="" xmlns:a14="http://schemas.microsoft.com/office/drawing/2010/main" w="9525">
                   <a:solidFill>
                     <a:srgbClr val="000000"/>
                   </a:solidFill>
@@ -2447,7 +2448,7 @@
             </a:ln>
             <a:extLst>
               <a:ext uri="{91240B29-F687-4f45-9708-019B960494DF}">
-                <a14:hiddenLine xmlns:a14="http://schemas.microsoft.com/office/drawing/2010/main" xmlns="" w="9525">
+                <a14:hiddenLine xmlns="" xmlns:a14="http://schemas.microsoft.com/office/drawing/2010/main" w="9525">
                   <a:solidFill>
                     <a:srgbClr val="000000"/>
                   </a:solidFill>
@@ -2515,7 +2516,7 @@
             </a:ln>
             <a:extLst>
               <a:ext uri="{91240B29-F687-4f45-9708-019B960494DF}">
-                <a14:hiddenLine xmlns:a14="http://schemas.microsoft.com/office/drawing/2010/main" xmlns="" w="9525">
+                <a14:hiddenLine xmlns="" xmlns:a14="http://schemas.microsoft.com/office/drawing/2010/main" w="9525">
                   <a:solidFill>
                     <a:srgbClr val="000000"/>
                   </a:solidFill>
@@ -2605,7 +2606,7 @@
             </a:ln>
             <a:extLst>
               <a:ext uri="{91240B29-F687-4f45-9708-019B960494DF}">
-                <a14:hiddenLine xmlns:a14="http://schemas.microsoft.com/office/drawing/2010/main" xmlns="" w="9525">
+                <a14:hiddenLine xmlns="" xmlns:a14="http://schemas.microsoft.com/office/drawing/2010/main" w="9525">
                   <a:solidFill>
                     <a:srgbClr val="000000"/>
                   </a:solidFill>
@@ -2673,7 +2674,7 @@
             </a:ln>
             <a:extLst>
               <a:ext uri="{91240B29-F687-4f45-9708-019B960494DF}">
-                <a14:hiddenLine xmlns:a14="http://schemas.microsoft.com/office/drawing/2010/main" xmlns="" w="9525">
+                <a14:hiddenLine xmlns="" xmlns:a14="http://schemas.microsoft.com/office/drawing/2010/main" w="9525">
                   <a:solidFill>
                     <a:srgbClr val="000000"/>
                   </a:solidFill>
@@ -2763,7 +2764,7 @@
             </a:ln>
             <a:extLst>
               <a:ext uri="{91240B29-F687-4f45-9708-019B960494DF}">
-                <a14:hiddenLine xmlns:a14="http://schemas.microsoft.com/office/drawing/2010/main" xmlns="" w="9525">
+                <a14:hiddenLine xmlns="" xmlns:a14="http://schemas.microsoft.com/office/drawing/2010/main" w="9525">
                   <a:solidFill>
                     <a:srgbClr val="000000"/>
                   </a:solidFill>
@@ -2797,7 +2798,7 @@
             </a:ln>
             <a:extLst>
               <a:ext uri="{91240B29-F687-4f45-9708-019B960494DF}">
-                <a14:hiddenLine xmlns:a14="http://schemas.microsoft.com/office/drawing/2010/main" xmlns="" w="9525">
+                <a14:hiddenLine xmlns="" xmlns:a14="http://schemas.microsoft.com/office/drawing/2010/main" w="9525">
                   <a:solidFill>
                     <a:srgbClr val="000000"/>
                   </a:solidFill>
@@ -2887,7 +2888,7 @@
             </a:ln>
             <a:extLst>
               <a:ext uri="{91240B29-F687-4f45-9708-019B960494DF}">
-                <a14:hiddenLine xmlns:a14="http://schemas.microsoft.com/office/drawing/2010/main" xmlns="" w="9525">
+                <a14:hiddenLine xmlns="" xmlns:a14="http://schemas.microsoft.com/office/drawing/2010/main" w="9525">
                   <a:solidFill>
                     <a:srgbClr val="000000"/>
                   </a:solidFill>
@@ -2949,7 +2950,7 @@
             </a:ln>
             <a:extLst>
               <a:ext uri="{91240B29-F687-4f45-9708-019B960494DF}">
-                <a14:hiddenLine xmlns:a14="http://schemas.microsoft.com/office/drawing/2010/main" xmlns="" w="9525">
+                <a14:hiddenLine xmlns="" xmlns:a14="http://schemas.microsoft.com/office/drawing/2010/main" w="9525">
                   <a:solidFill>
                     <a:srgbClr val="000000"/>
                   </a:solidFill>
@@ -3011,7 +3012,7 @@
             </a:ln>
             <a:extLst>
               <a:ext uri="{91240B29-F687-4f45-9708-019B960494DF}">
-                <a14:hiddenLine xmlns:a14="http://schemas.microsoft.com/office/drawing/2010/main" xmlns="" w="9525">
+                <a14:hiddenLine xmlns="" xmlns:a14="http://schemas.microsoft.com/office/drawing/2010/main" w="9525">
                   <a:solidFill>
                     <a:srgbClr val="000000"/>
                   </a:solidFill>
@@ -3101,7 +3102,7 @@
             </a:ln>
             <a:extLst>
               <a:ext uri="{91240B29-F687-4f45-9708-019B960494DF}">
-                <a14:hiddenLine xmlns:a14="http://schemas.microsoft.com/office/drawing/2010/main" xmlns="" w="9525">
+                <a14:hiddenLine xmlns="" xmlns:a14="http://schemas.microsoft.com/office/drawing/2010/main" w="9525">
                   <a:solidFill>
                     <a:srgbClr val="000000"/>
                   </a:solidFill>
@@ -3169,7 +3170,7 @@
             </a:ln>
             <a:extLst>
               <a:ext uri="{91240B29-F687-4f45-9708-019B960494DF}">
-                <a14:hiddenLine xmlns:a14="http://schemas.microsoft.com/office/drawing/2010/main" xmlns="" w="9525">
+                <a14:hiddenLine xmlns="" xmlns:a14="http://schemas.microsoft.com/office/drawing/2010/main" w="9525">
                   <a:solidFill>
                     <a:srgbClr val="000000"/>
                   </a:solidFill>
@@ -3231,7 +3232,7 @@
             </a:ln>
             <a:extLst>
               <a:ext uri="{91240B29-F687-4f45-9708-019B960494DF}">
-                <a14:hiddenLine xmlns:a14="http://schemas.microsoft.com/office/drawing/2010/main" xmlns="" w="9525">
+                <a14:hiddenLine xmlns="" xmlns:a14="http://schemas.microsoft.com/office/drawing/2010/main" w="9525">
                   <a:solidFill>
                     <a:srgbClr val="000000"/>
                   </a:solidFill>
@@ -3321,7 +3322,7 @@
             </a:ln>
             <a:extLst>
               <a:ext uri="{91240B29-F687-4f45-9708-019B960494DF}">
-                <a14:hiddenLine xmlns:a14="http://schemas.microsoft.com/office/drawing/2010/main" xmlns="" w="9525">
+                <a14:hiddenLine xmlns="" xmlns:a14="http://schemas.microsoft.com/office/drawing/2010/main" w="9525">
                   <a:solidFill>
                     <a:srgbClr val="000000"/>
                   </a:solidFill>
@@ -3383,7 +3384,7 @@
             </a:ln>
             <a:extLst>
               <a:ext uri="{91240B29-F687-4f45-9708-019B960494DF}">
-                <a14:hiddenLine xmlns:a14="http://schemas.microsoft.com/office/drawing/2010/main" xmlns="" w="9525">
+                <a14:hiddenLine xmlns="" xmlns:a14="http://schemas.microsoft.com/office/drawing/2010/main" w="9525">
                   <a:solidFill>
                     <a:srgbClr val="000000"/>
                   </a:solidFill>
@@ -3473,7 +3474,7 @@
             </a:ln>
             <a:extLst>
               <a:ext uri="{91240B29-F687-4f45-9708-019B960494DF}">
-                <a14:hiddenLine xmlns:a14="http://schemas.microsoft.com/office/drawing/2010/main" xmlns="" w="9525">
+                <a14:hiddenLine xmlns="" xmlns:a14="http://schemas.microsoft.com/office/drawing/2010/main" w="9525">
                   <a:solidFill>
                     <a:srgbClr val="000000"/>
                   </a:solidFill>
@@ -3535,7 +3536,7 @@
             </a:ln>
             <a:extLst>
               <a:ext uri="{91240B29-F687-4f45-9708-019B960494DF}">
-                <a14:hiddenLine xmlns:a14="http://schemas.microsoft.com/office/drawing/2010/main" xmlns="" w="9525">
+                <a14:hiddenLine xmlns="" xmlns:a14="http://schemas.microsoft.com/office/drawing/2010/main" w="9525">
                   <a:solidFill>
                     <a:srgbClr val="000000"/>
                   </a:solidFill>
@@ -3625,7 +3626,7 @@
             </a:ln>
             <a:extLst>
               <a:ext uri="{91240B29-F687-4f45-9708-019B960494DF}">
-                <a14:hiddenLine xmlns:a14="http://schemas.microsoft.com/office/drawing/2010/main" xmlns="" w="9525">
+                <a14:hiddenLine xmlns="" xmlns:a14="http://schemas.microsoft.com/office/drawing/2010/main" w="9525">
                   <a:solidFill>
                     <a:srgbClr val="000000"/>
                   </a:solidFill>
@@ -3659,7 +3660,7 @@
             </a:ln>
             <a:extLst>
               <a:ext uri="{91240B29-F687-4f45-9708-019B960494DF}">
-                <a14:hiddenLine xmlns:a14="http://schemas.microsoft.com/office/drawing/2010/main" xmlns="" w="9525">
+                <a14:hiddenLine xmlns="" xmlns:a14="http://schemas.microsoft.com/office/drawing/2010/main" w="9525">
                   <a:solidFill>
                     <a:srgbClr val="000000"/>
                   </a:solidFill>
@@ -3724,7 +3725,7 @@
             </a:ln>
             <a:extLst>
               <a:ext uri="{91240B29-F687-4f45-9708-019B960494DF}">
-                <a14:hiddenLine xmlns:a14="http://schemas.microsoft.com/office/drawing/2010/main" xmlns="" w="9525">
+                <a14:hiddenLine xmlns="" xmlns:a14="http://schemas.microsoft.com/office/drawing/2010/main" w="9525">
                   <a:solidFill>
                     <a:srgbClr val="000000"/>
                   </a:solidFill>
@@ -3814,7 +3815,7 @@
             </a:ln>
             <a:extLst>
               <a:ext uri="{91240B29-F687-4f45-9708-019B960494DF}">
-                <a14:hiddenLine xmlns:a14="http://schemas.microsoft.com/office/drawing/2010/main" xmlns="" w="9525">
+                <a14:hiddenLine xmlns="" xmlns:a14="http://schemas.microsoft.com/office/drawing/2010/main" w="9525">
                   <a:solidFill>
                     <a:srgbClr val="000000"/>
                   </a:solidFill>
@@ -3876,7 +3877,7 @@
             </a:ln>
             <a:extLst>
               <a:ext uri="{91240B29-F687-4f45-9708-019B960494DF}">
-                <a14:hiddenLine xmlns:a14="http://schemas.microsoft.com/office/drawing/2010/main" xmlns="" w="9525">
+                <a14:hiddenLine xmlns="" xmlns:a14="http://schemas.microsoft.com/office/drawing/2010/main" w="9525">
                   <a:solidFill>
                     <a:srgbClr val="000000"/>
                   </a:solidFill>
@@ -3966,7 +3967,7 @@
             </a:ln>
             <a:extLst>
               <a:ext uri="{91240B29-F687-4f45-9708-019B960494DF}">
-                <a14:hiddenLine xmlns:a14="http://schemas.microsoft.com/office/drawing/2010/main" xmlns="" w="9525">
+                <a14:hiddenLine xmlns="" xmlns:a14="http://schemas.microsoft.com/office/drawing/2010/main" w="9525">
                   <a:solidFill>
                     <a:srgbClr val="000000"/>
                   </a:solidFill>
@@ -4056,7 +4057,7 @@
             </a:ln>
             <a:extLst>
               <a:ext uri="{91240B29-F687-4f45-9708-019B960494DF}">
-                <a14:hiddenLine xmlns:a14="http://schemas.microsoft.com/office/drawing/2010/main" xmlns="" w="9525">
+                <a14:hiddenLine xmlns="" xmlns:a14="http://schemas.microsoft.com/office/drawing/2010/main" w="9525">
                   <a:solidFill>
                     <a:srgbClr val="000000"/>
                   </a:solidFill>
@@ -4121,7 +4122,7 @@
             </a:ln>
             <a:extLst>
               <a:ext uri="{91240B29-F687-4f45-9708-019B960494DF}">
-                <a14:hiddenLine xmlns:a14="http://schemas.microsoft.com/office/drawing/2010/main" xmlns="" w="9525">
+                <a14:hiddenLine xmlns="" xmlns:a14="http://schemas.microsoft.com/office/drawing/2010/main" w="9525">
                   <a:solidFill>
                     <a:srgbClr val="000000"/>
                   </a:solidFill>
@@ -4183,7 +4184,7 @@
             </a:ln>
             <a:extLst>
               <a:ext uri="{91240B29-F687-4f45-9708-019B960494DF}">
-                <a14:hiddenLine xmlns:a14="http://schemas.microsoft.com/office/drawing/2010/main" xmlns="" w="9525">
+                <a14:hiddenLine xmlns="" xmlns:a14="http://schemas.microsoft.com/office/drawing/2010/main" w="9525">
                   <a:solidFill>
                     <a:srgbClr val="000000"/>
                   </a:solidFill>
@@ -4273,7 +4274,7 @@
             </a:ln>
             <a:extLst>
               <a:ext uri="{91240B29-F687-4f45-9708-019B960494DF}">
-                <a14:hiddenLine xmlns:a14="http://schemas.microsoft.com/office/drawing/2010/main" xmlns="" w="9525">
+                <a14:hiddenLine xmlns="" xmlns:a14="http://schemas.microsoft.com/office/drawing/2010/main" w="9525">
                   <a:solidFill>
                     <a:srgbClr val="000000"/>
                   </a:solidFill>
@@ -4363,7 +4364,7 @@
             </a:ln>
             <a:extLst>
               <a:ext uri="{91240B29-F687-4f45-9708-019B960494DF}">
-                <a14:hiddenLine xmlns:a14="http://schemas.microsoft.com/office/drawing/2010/main" xmlns="" w="9525">
+                <a14:hiddenLine xmlns="" xmlns:a14="http://schemas.microsoft.com/office/drawing/2010/main" w="9525">
                   <a:solidFill>
                     <a:srgbClr val="000000"/>
                   </a:solidFill>
@@ -4425,7 +4426,7 @@
             </a:ln>
             <a:extLst>
               <a:ext uri="{91240B29-F687-4f45-9708-019B960494DF}">
-                <a14:hiddenLine xmlns:a14="http://schemas.microsoft.com/office/drawing/2010/main" xmlns="" w="9525">
+                <a14:hiddenLine xmlns="" xmlns:a14="http://schemas.microsoft.com/office/drawing/2010/main" w="9525">
                   <a:solidFill>
                     <a:srgbClr val="000000"/>
                   </a:solidFill>
@@ -4545,7 +4546,7 @@
             </a:ln>
             <a:extLst>
               <a:ext uri="{91240B29-F687-4f45-9708-019B960494DF}">
-                <a14:hiddenLine xmlns:a14="http://schemas.microsoft.com/office/drawing/2010/main" xmlns="" w="9525">
+                <a14:hiddenLine xmlns="" xmlns:a14="http://schemas.microsoft.com/office/drawing/2010/main" w="9525">
                   <a:solidFill>
                     <a:srgbClr val="000000"/>
                   </a:solidFill>
@@ -4613,7 +4614,7 @@
             </a:ln>
             <a:extLst>
               <a:ext uri="{91240B29-F687-4f45-9708-019B960494DF}">
-                <a14:hiddenLine xmlns:a14="http://schemas.microsoft.com/office/drawing/2010/main" xmlns="" w="9525">
+                <a14:hiddenLine xmlns="" xmlns:a14="http://schemas.microsoft.com/office/drawing/2010/main" w="9525">
                   <a:solidFill>
                     <a:srgbClr val="000000"/>
                   </a:solidFill>
@@ -4703,7 +4704,7 @@
             </a:ln>
             <a:extLst>
               <a:ext uri="{91240B29-F687-4f45-9708-019B960494DF}">
-                <a14:hiddenLine xmlns:a14="http://schemas.microsoft.com/office/drawing/2010/main" xmlns="" w="9525">
+                <a14:hiddenLine xmlns="" xmlns:a14="http://schemas.microsoft.com/office/drawing/2010/main" w="9525">
                   <a:solidFill>
                     <a:srgbClr val="000000"/>
                   </a:solidFill>
@@ -4843,7 +4844,7 @@
           <a:p>
             <a:fld id="{4313F670-7F9A-774D-B73D-573401E44297}" type="datetime1">
               <a:rPr lang="en-US" smtClean="0"/>
-              <a:t>7/30/26</a:t>
+              <a:t>8/3/26</a:t>
             </a:fld>
             <a:endParaRPr lang="en-US"/>
           </a:p>
@@ -5110,7 +5111,7 @@
           <a:p>
             <a:fld id="{446F9669-A8A7-2D40-9D01-B35FC337AA30}" type="datetime1">
               <a:rPr lang="en-US" smtClean="0"/>
-              <a:t>7/30/26</a:t>
+              <a:t>8/3/26</a:t>
             </a:fld>
             <a:endParaRPr lang="en-US"/>
           </a:p>
@@ -5306,7 +5307,7 @@
           <a:p>
             <a:fld id="{FA76CF18-F41B-6B48-B3E5-599E9795C2C3}" type="datetime1">
               <a:rPr lang="en-US" smtClean="0"/>
-              <a:t>7/30/26</a:t>
+              <a:t>8/3/26</a:t>
             </a:fld>
             <a:endParaRPr lang="en-US"/>
           </a:p>
@@ -5569,7 +5570,7 @@
           <a:p>
             <a:fld id="{B9654854-6457-164F-A077-6B3035079B82}" type="datetime1">
               <a:rPr lang="en-US" smtClean="0"/>
-              <a:t>7/30/26</a:t>
+              <a:t>8/3/26</a:t>
             </a:fld>
             <a:endParaRPr lang="en-US"/>
           </a:p>
@@ -6003,7 +6004,7 @@
           <a:p>
             <a:fld id="{CE3DBFD7-E611-8C40-AC73-0C29FF63F0CD}" type="datetime1">
               <a:rPr lang="en-US" smtClean="0"/>
-              <a:t>7/30/26</a:t>
+              <a:t>8/3/26</a:t>
             </a:fld>
             <a:endParaRPr lang="en-US"/>
           </a:p>
@@ -6549,7 +6550,7 @@
           <a:p>
             <a:fld id="{C8B63B06-0493-2840-9F37-30C9412BBF17}" type="datetime1">
               <a:rPr lang="en-US" smtClean="0"/>
-              <a:t>7/30/26</a:t>
+              <a:t>8/3/26</a:t>
             </a:fld>
             <a:endParaRPr lang="en-US"/>
           </a:p>
@@ -7269,7 +7270,7 @@
           <a:p>
             <a:fld id="{72B5C0FA-8C46-E84D-B6D7-B673F2CA0A0E}" type="datetime1">
               <a:rPr lang="en-US" smtClean="0"/>
-              <a:t>7/30/26</a:t>
+              <a:t>8/3/26</a:t>
             </a:fld>
             <a:endParaRPr lang="en-US"/>
           </a:p>
@@ -7439,7 +7440,7 @@
           <a:p>
             <a:fld id="{60B9CDE1-97B4-BF46-B69C-B86855B18820}" type="datetime1">
               <a:rPr lang="en-US" smtClean="0"/>
-              <a:t>7/30/26</a:t>
+              <a:t>8/3/26</a:t>
             </a:fld>
             <a:endParaRPr lang="en-US"/>
           </a:p>
@@ -7619,7 +7620,7 @@
           <a:p>
             <a:fld id="{BE51D3A4-F9E5-FD49-AA87-B395F50451DC}" type="datetime1">
               <a:rPr lang="en-US" smtClean="0"/>
-              <a:t>7/30/26</a:t>
+              <a:t>8/3/26</a:t>
             </a:fld>
             <a:endParaRPr lang="en-US"/>
           </a:p>
@@ -7789,7 +7790,7 @@
           <a:p>
             <a:fld id="{880DFB37-B0AE-9449-85EC-14F9C83B6084}" type="datetime1">
               <a:rPr lang="en-US" smtClean="0"/>
-              <a:t>7/30/26</a:t>
+              <a:t>8/3/26</a:t>
             </a:fld>
             <a:endParaRPr lang="en-US"/>
           </a:p>
@@ -8039,7 +8040,7 @@
           <a:p>
             <a:fld id="{C939124A-616E-6944-A21A-1839F5DBE7BB}" type="datetime1">
               <a:rPr lang="en-US" smtClean="0"/>
-              <a:t>7/30/26</a:t>
+              <a:t>8/3/26</a:t>
             </a:fld>
             <a:endParaRPr lang="en-US"/>
           </a:p>
@@ -8271,7 +8272,7 @@
           <a:p>
             <a:fld id="{C6E9A026-D48C-FD43-8676-CD625DD5D84B}" type="datetime1">
               <a:rPr lang="en-US" smtClean="0"/>
-              <a:t>7/30/26</a:t>
+              <a:t>8/3/26</a:t>
             </a:fld>
             <a:endParaRPr lang="en-US"/>
           </a:p>
@@ -8657,7 +8658,7 @@
           <a:p>
             <a:fld id="{EA35111E-23A3-1440-99A3-C4C665908E3D}" type="datetime1">
               <a:rPr lang="en-US" smtClean="0"/>
-              <a:t>7/30/26</a:t>
+              <a:t>8/3/26</a:t>
             </a:fld>
             <a:endParaRPr lang="en-US"/>
           </a:p>
@@ -8780,7 +8781,7 @@
           <a:p>
             <a:fld id="{249983B9-88EF-D74B-BA6D-6A3BF17C2B38}" type="datetime1">
               <a:rPr lang="en-US" smtClean="0"/>
-              <a:t>7/30/26</a:t>
+              <a:t>8/3/26</a:t>
             </a:fld>
             <a:endParaRPr lang="en-US"/>
           </a:p>
@@ -8875,7 +8876,7 @@
           <a:p>
             <a:fld id="{E2A00AEF-B4EC-084A-8DB8-A225C7981CBB}" type="datetime1">
               <a:rPr lang="en-US" smtClean="0"/>
-              <a:t>7/30/26</a:t>
+              <a:t>8/3/26</a:t>
             </a:fld>
             <a:endParaRPr lang="en-US"/>
           </a:p>
@@ -9124,7 +9125,7 @@
           <a:p>
             <a:fld id="{97860299-21CD-A94A-A7B0-44E787F8D42C}" type="datetime1">
               <a:rPr lang="en-US" smtClean="0"/>
-              <a:t>7/30/26</a:t>
+              <a:t>8/3/26</a:t>
             </a:fld>
             <a:endParaRPr lang="en-US"/>
           </a:p>
@@ -9409,7 +9410,7 @@
           <a:p>
             <a:fld id="{3DFD19CF-4E62-D246-BA61-7B528271315F}" type="datetime1">
               <a:rPr lang="en-US" smtClean="0"/>
-              <a:t>7/30/26</a:t>
+              <a:t>8/3/26</a:t>
             </a:fld>
             <a:endParaRPr lang="en-US"/>
           </a:p>
@@ -9532,7 +9533,7 @@
           <a:noFill/>
           <a:extLst>
             <a:ext uri="{909E8E84-426E-40dd-AFC4-6F175D3DCCD1}">
-              <a14:hiddenFill xmlns:a14="http://schemas.microsoft.com/office/drawing/2010/main" xmlns="">
+              <a14:hiddenFill xmlns="" xmlns:a14="http://schemas.microsoft.com/office/drawing/2010/main">
                 <a:solidFill>
                   <a:srgbClr val="FFFFFF"/>
                 </a:solidFill>
@@ -9606,7 +9607,7 @@
               </a:ln>
               <a:extLst>
                 <a:ext uri="{91240B29-F687-4f45-9708-019B960494DF}">
-                  <a14:hiddenLine xmlns:a14="http://schemas.microsoft.com/office/drawing/2010/main" xmlns="" w="9525">
+                  <a14:hiddenLine xmlns="" xmlns:a14="http://schemas.microsoft.com/office/drawing/2010/main" w="9525">
                     <a:solidFill>
                       <a:srgbClr val="000000"/>
                     </a:solidFill>
@@ -9696,7 +9697,7 @@
               </a:ln>
               <a:extLst>
                 <a:ext uri="{91240B29-F687-4f45-9708-019B960494DF}">
-                  <a14:hiddenLine xmlns:a14="http://schemas.microsoft.com/office/drawing/2010/main" xmlns="" w="9525">
+                  <a14:hiddenLine xmlns="" xmlns:a14="http://schemas.microsoft.com/office/drawing/2010/main" w="9525">
                     <a:solidFill>
                       <a:srgbClr val="000000"/>
                     </a:solidFill>
@@ -9786,7 +9787,7 @@
               </a:ln>
               <a:extLst>
                 <a:ext uri="{91240B29-F687-4f45-9708-019B960494DF}">
-                  <a14:hiddenLine xmlns:a14="http://schemas.microsoft.com/office/drawing/2010/main" xmlns="" w="9525">
+                  <a14:hiddenLine xmlns="" xmlns:a14="http://schemas.microsoft.com/office/drawing/2010/main" w="9525">
                     <a:solidFill>
                       <a:srgbClr val="000000"/>
                     </a:solidFill>
@@ -9848,7 +9849,7 @@
               </a:ln>
               <a:extLst>
                 <a:ext uri="{91240B29-F687-4f45-9708-019B960494DF}">
-                  <a14:hiddenLine xmlns:a14="http://schemas.microsoft.com/office/drawing/2010/main" xmlns="" w="9525">
+                  <a14:hiddenLine xmlns="" xmlns:a14="http://schemas.microsoft.com/office/drawing/2010/main" w="9525">
                     <a:solidFill>
                       <a:srgbClr val="000000"/>
                     </a:solidFill>
@@ -9938,7 +9939,7 @@
               </a:ln>
               <a:extLst>
                 <a:ext uri="{91240B29-F687-4f45-9708-019B960494DF}">
-                  <a14:hiddenLine xmlns:a14="http://schemas.microsoft.com/office/drawing/2010/main" xmlns="" w="9525">
+                  <a14:hiddenLine xmlns="" xmlns:a14="http://schemas.microsoft.com/office/drawing/2010/main" w="9525">
                     <a:solidFill>
                       <a:srgbClr val="000000"/>
                     </a:solidFill>
@@ -10000,7 +10001,7 @@
               </a:ln>
               <a:extLst>
                 <a:ext uri="{91240B29-F687-4f45-9708-019B960494DF}">
-                  <a14:hiddenLine xmlns:a14="http://schemas.microsoft.com/office/drawing/2010/main" xmlns="" w="9525">
+                  <a14:hiddenLine xmlns="" xmlns:a14="http://schemas.microsoft.com/office/drawing/2010/main" w="9525">
                     <a:solidFill>
                       <a:srgbClr val="000000"/>
                     </a:solidFill>
@@ -10062,7 +10063,7 @@
               </a:ln>
               <a:extLst>
                 <a:ext uri="{91240B29-F687-4f45-9708-019B960494DF}">
-                  <a14:hiddenLine xmlns:a14="http://schemas.microsoft.com/office/drawing/2010/main" xmlns="" w="9525">
+                  <a14:hiddenLine xmlns="" xmlns:a14="http://schemas.microsoft.com/office/drawing/2010/main" w="9525">
                     <a:solidFill>
                       <a:srgbClr val="000000"/>
                     </a:solidFill>
@@ -10152,7 +10153,7 @@
               </a:ln>
               <a:extLst>
                 <a:ext uri="{91240B29-F687-4f45-9708-019B960494DF}">
-                  <a14:hiddenLine xmlns:a14="http://schemas.microsoft.com/office/drawing/2010/main" xmlns="" w="9525">
+                  <a14:hiddenLine xmlns="" xmlns:a14="http://schemas.microsoft.com/office/drawing/2010/main" w="9525">
                     <a:solidFill>
                       <a:srgbClr val="000000"/>
                     </a:solidFill>
@@ -10242,7 +10243,7 @@
               </a:ln>
               <a:extLst>
                 <a:ext uri="{91240B29-F687-4f45-9708-019B960494DF}">
-                  <a14:hiddenLine xmlns:a14="http://schemas.microsoft.com/office/drawing/2010/main" xmlns="" w="9525">
+                  <a14:hiddenLine xmlns="" xmlns:a14="http://schemas.microsoft.com/office/drawing/2010/main" w="9525">
                     <a:solidFill>
                       <a:srgbClr val="000000"/>
                     </a:solidFill>
@@ -10304,7 +10305,7 @@
               </a:ln>
               <a:extLst>
                 <a:ext uri="{91240B29-F687-4f45-9708-019B960494DF}">
-                  <a14:hiddenLine xmlns:a14="http://schemas.microsoft.com/office/drawing/2010/main" xmlns="" w="9525">
+                  <a14:hiddenLine xmlns="" xmlns:a14="http://schemas.microsoft.com/office/drawing/2010/main" w="9525">
                     <a:solidFill>
                       <a:srgbClr val="000000"/>
                     </a:solidFill>
@@ -10414,7 +10415,7 @@
               </a:ln>
               <a:extLst>
                 <a:ext uri="{91240B29-F687-4f45-9708-019B960494DF}">
-                  <a14:hiddenLine xmlns:a14="http://schemas.microsoft.com/office/drawing/2010/main" xmlns="" w="9525">
+                  <a14:hiddenLine xmlns="" xmlns:a14="http://schemas.microsoft.com/office/drawing/2010/main" w="9525">
                     <a:solidFill>
                       <a:srgbClr val="000000"/>
                     </a:solidFill>
@@ -10498,7 +10499,7 @@
               </a:ln>
               <a:extLst>
                 <a:ext uri="{91240B29-F687-4f45-9708-019B960494DF}">
-                  <a14:hiddenLine xmlns:a14="http://schemas.microsoft.com/office/drawing/2010/main" xmlns="" w="9525">
+                  <a14:hiddenLine xmlns="" xmlns:a14="http://schemas.microsoft.com/office/drawing/2010/main" w="9525">
                     <a:solidFill>
                       <a:srgbClr val="000000"/>
                     </a:solidFill>
@@ -10560,7 +10561,7 @@
               </a:ln>
               <a:extLst>
                 <a:ext uri="{91240B29-F687-4f45-9708-019B960494DF}">
-                  <a14:hiddenLine xmlns:a14="http://schemas.microsoft.com/office/drawing/2010/main" xmlns="" w="9525">
+                  <a14:hiddenLine xmlns="" xmlns:a14="http://schemas.microsoft.com/office/drawing/2010/main" w="9525">
                     <a:solidFill>
                       <a:srgbClr val="000000"/>
                     </a:solidFill>
@@ -10622,7 +10623,7 @@
               </a:ln>
               <a:extLst>
                 <a:ext uri="{91240B29-F687-4f45-9708-019B960494DF}">
-                  <a14:hiddenLine xmlns:a14="http://schemas.microsoft.com/office/drawing/2010/main" xmlns="" w="9525">
+                  <a14:hiddenLine xmlns="" xmlns:a14="http://schemas.microsoft.com/office/drawing/2010/main" w="9525">
                     <a:solidFill>
                       <a:srgbClr val="000000"/>
                     </a:solidFill>
@@ -10712,7 +10713,7 @@
               </a:ln>
               <a:extLst>
                 <a:ext uri="{91240B29-F687-4f45-9708-019B960494DF}">
-                  <a14:hiddenLine xmlns:a14="http://schemas.microsoft.com/office/drawing/2010/main" xmlns="" w="9525">
+                  <a14:hiddenLine xmlns="" xmlns:a14="http://schemas.microsoft.com/office/drawing/2010/main" w="9525">
                     <a:solidFill>
                       <a:srgbClr val="000000"/>
                     </a:solidFill>
@@ -10746,7 +10747,7 @@
               </a:ln>
               <a:extLst>
                 <a:ext uri="{91240B29-F687-4f45-9708-019B960494DF}">
-                  <a14:hiddenLine xmlns:a14="http://schemas.microsoft.com/office/drawing/2010/main" xmlns="" w="9525">
+                  <a14:hiddenLine xmlns="" xmlns:a14="http://schemas.microsoft.com/office/drawing/2010/main" w="9525">
                     <a:solidFill>
                       <a:srgbClr val="000000"/>
                     </a:solidFill>
@@ -10811,7 +10812,7 @@
               </a:ln>
               <a:extLst>
                 <a:ext uri="{91240B29-F687-4f45-9708-019B960494DF}">
-                  <a14:hiddenLine xmlns:a14="http://schemas.microsoft.com/office/drawing/2010/main" xmlns="" w="9525">
+                  <a14:hiddenLine xmlns="" xmlns:a14="http://schemas.microsoft.com/office/drawing/2010/main" w="9525">
                     <a:solidFill>
                       <a:srgbClr val="000000"/>
                     </a:solidFill>
@@ -10901,7 +10902,7 @@
               </a:ln>
               <a:extLst>
                 <a:ext uri="{91240B29-F687-4f45-9708-019B960494DF}">
-                  <a14:hiddenLine xmlns:a14="http://schemas.microsoft.com/office/drawing/2010/main" xmlns="" w="9525">
+                  <a14:hiddenLine xmlns="" xmlns:a14="http://schemas.microsoft.com/office/drawing/2010/main" w="9525">
                     <a:solidFill>
                       <a:srgbClr val="000000"/>
                     </a:solidFill>
@@ -10963,7 +10964,7 @@
               </a:ln>
               <a:extLst>
                 <a:ext uri="{91240B29-F687-4f45-9708-019B960494DF}">
-                  <a14:hiddenLine xmlns:a14="http://schemas.microsoft.com/office/drawing/2010/main" xmlns="" w="9525">
+                  <a14:hiddenLine xmlns="" xmlns:a14="http://schemas.microsoft.com/office/drawing/2010/main" w="9525">
                     <a:solidFill>
                       <a:srgbClr val="000000"/>
                     </a:solidFill>
@@ -11053,7 +11054,7 @@
               </a:ln>
               <a:extLst>
                 <a:ext uri="{91240B29-F687-4f45-9708-019B960494DF}">
-                  <a14:hiddenLine xmlns:a14="http://schemas.microsoft.com/office/drawing/2010/main" xmlns="" w="9525">
+                  <a14:hiddenLine xmlns="" xmlns:a14="http://schemas.microsoft.com/office/drawing/2010/main" w="9525">
                     <a:solidFill>
                       <a:srgbClr val="000000"/>
                     </a:solidFill>
@@ -11118,7 +11119,7 @@
               </a:ln>
               <a:extLst>
                 <a:ext uri="{91240B29-F687-4f45-9708-019B960494DF}">
-                  <a14:hiddenLine xmlns:a14="http://schemas.microsoft.com/office/drawing/2010/main" xmlns="" w="9525">
+                  <a14:hiddenLine xmlns="" xmlns:a14="http://schemas.microsoft.com/office/drawing/2010/main" w="9525">
                     <a:solidFill>
                       <a:srgbClr val="000000"/>
                     </a:solidFill>
@@ -11180,7 +11181,7 @@
               </a:ln>
               <a:extLst>
                 <a:ext uri="{91240B29-F687-4f45-9708-019B960494DF}">
-                  <a14:hiddenLine xmlns:a14="http://schemas.microsoft.com/office/drawing/2010/main" xmlns="" w="9525">
+                  <a14:hiddenLine xmlns="" xmlns:a14="http://schemas.microsoft.com/office/drawing/2010/main" w="9525">
                     <a:solidFill>
                       <a:srgbClr val="000000"/>
                     </a:solidFill>
@@ -11270,7 +11271,7 @@
               </a:ln>
               <a:extLst>
                 <a:ext uri="{91240B29-F687-4f45-9708-019B960494DF}">
-                  <a14:hiddenLine xmlns:a14="http://schemas.microsoft.com/office/drawing/2010/main" xmlns="" w="9525">
+                  <a14:hiddenLine xmlns="" xmlns:a14="http://schemas.microsoft.com/office/drawing/2010/main" w="9525">
                     <a:solidFill>
                       <a:srgbClr val="000000"/>
                     </a:solidFill>
@@ -11360,7 +11361,7 @@
               </a:ln>
               <a:extLst>
                 <a:ext uri="{91240B29-F687-4f45-9708-019B960494DF}">
-                  <a14:hiddenLine xmlns:a14="http://schemas.microsoft.com/office/drawing/2010/main" xmlns="" w="9525">
+                  <a14:hiddenLine xmlns="" xmlns:a14="http://schemas.microsoft.com/office/drawing/2010/main" w="9525">
                     <a:solidFill>
                       <a:srgbClr val="000000"/>
                     </a:solidFill>
@@ -11425,7 +11426,7 @@
               </a:ln>
               <a:extLst>
                 <a:ext uri="{91240B29-F687-4f45-9708-019B960494DF}">
-                  <a14:hiddenLine xmlns:a14="http://schemas.microsoft.com/office/drawing/2010/main" xmlns="" w="9525">
+                  <a14:hiddenLine xmlns="" xmlns:a14="http://schemas.microsoft.com/office/drawing/2010/main" w="9525">
                     <a:solidFill>
                       <a:srgbClr val="000000"/>
                     </a:solidFill>
@@ -11545,7 +11546,7 @@
               </a:ln>
               <a:extLst>
                 <a:ext uri="{91240B29-F687-4f45-9708-019B960494DF}">
-                  <a14:hiddenLine xmlns:a14="http://schemas.microsoft.com/office/drawing/2010/main" xmlns="" w="9525">
+                  <a14:hiddenLine xmlns="" xmlns:a14="http://schemas.microsoft.com/office/drawing/2010/main" w="9525">
                     <a:solidFill>
                       <a:srgbClr val="000000"/>
                     </a:solidFill>
@@ -11626,7 +11627,7 @@
               </a:ln>
               <a:extLst>
                 <a:ext uri="{91240B29-F687-4f45-9708-019B960494DF}">
-                  <a14:hiddenLine xmlns:a14="http://schemas.microsoft.com/office/drawing/2010/main" xmlns="" w="9525">
+                  <a14:hiddenLine xmlns="" xmlns:a14="http://schemas.microsoft.com/office/drawing/2010/main" w="9525">
                     <a:solidFill>
                       <a:srgbClr val="000000"/>
                     </a:solidFill>
@@ -11741,7 +11742,7 @@
               </a:ln>
               <a:extLst>
                 <a:ext uri="{91240B29-F687-4f45-9708-019B960494DF}">
-                  <a14:hiddenLine xmlns:a14="http://schemas.microsoft.com/office/drawing/2010/main" xmlns="" w="9525">
+                  <a14:hiddenLine xmlns="" xmlns:a14="http://schemas.microsoft.com/office/drawing/2010/main" w="9525">
                     <a:solidFill>
                       <a:srgbClr val="000000"/>
                     </a:solidFill>
@@ -11831,7 +11832,7 @@
               </a:ln>
               <a:extLst>
                 <a:ext uri="{91240B29-F687-4f45-9708-019B960494DF}">
-                  <a14:hiddenLine xmlns:a14="http://schemas.microsoft.com/office/drawing/2010/main" xmlns="" w="9525">
+                  <a14:hiddenLine xmlns="" xmlns:a14="http://schemas.microsoft.com/office/drawing/2010/main" w="9525">
                     <a:solidFill>
                       <a:srgbClr val="000000"/>
                     </a:solidFill>
@@ -11896,7 +11897,7 @@
               </a:ln>
               <a:extLst>
                 <a:ext uri="{91240B29-F687-4f45-9708-019B960494DF}">
-                  <a14:hiddenLine xmlns:a14="http://schemas.microsoft.com/office/drawing/2010/main" xmlns="" w="9525">
+                  <a14:hiddenLine xmlns="" xmlns:a14="http://schemas.microsoft.com/office/drawing/2010/main" w="9525">
                     <a:solidFill>
                       <a:srgbClr val="000000"/>
                     </a:solidFill>
@@ -11986,7 +11987,7 @@
               </a:ln>
               <a:extLst>
                 <a:ext uri="{91240B29-F687-4f45-9708-019B960494DF}">
-                  <a14:hiddenLine xmlns:a14="http://schemas.microsoft.com/office/drawing/2010/main" xmlns="" w="9525">
+                  <a14:hiddenLine xmlns="" xmlns:a14="http://schemas.microsoft.com/office/drawing/2010/main" w="9525">
                     <a:solidFill>
                       <a:srgbClr val="000000"/>
                     </a:solidFill>
@@ -12054,7 +12055,7 @@
               </a:ln>
               <a:extLst>
                 <a:ext uri="{91240B29-F687-4f45-9708-019B960494DF}">
-                  <a14:hiddenLine xmlns:a14="http://schemas.microsoft.com/office/drawing/2010/main" xmlns="" w="9525">
+                  <a14:hiddenLine xmlns="" xmlns:a14="http://schemas.microsoft.com/office/drawing/2010/main" w="9525">
                     <a:solidFill>
                       <a:srgbClr val="000000"/>
                     </a:solidFill>
@@ -12144,7 +12145,7 @@
               </a:ln>
               <a:extLst>
                 <a:ext uri="{91240B29-F687-4f45-9708-019B960494DF}">
-                  <a14:hiddenLine xmlns:a14="http://schemas.microsoft.com/office/drawing/2010/main" xmlns="" w="9525">
+                  <a14:hiddenLine xmlns="" xmlns:a14="http://schemas.microsoft.com/office/drawing/2010/main" w="9525">
                     <a:solidFill>
                       <a:srgbClr val="000000"/>
                     </a:solidFill>
@@ -12212,7 +12213,7 @@
               </a:ln>
               <a:extLst>
                 <a:ext uri="{91240B29-F687-4f45-9708-019B960494DF}">
-                  <a14:hiddenLine xmlns:a14="http://schemas.microsoft.com/office/drawing/2010/main" xmlns="" w="9525">
+                  <a14:hiddenLine xmlns="" xmlns:a14="http://schemas.microsoft.com/office/drawing/2010/main" w="9525">
                     <a:solidFill>
                       <a:srgbClr val="000000"/>
                     </a:solidFill>
@@ -12302,7 +12303,7 @@
               </a:ln>
               <a:extLst>
                 <a:ext uri="{91240B29-F687-4f45-9708-019B960494DF}">
-                  <a14:hiddenLine xmlns:a14="http://schemas.microsoft.com/office/drawing/2010/main" xmlns="" w="9525">
+                  <a14:hiddenLine xmlns="" xmlns:a14="http://schemas.microsoft.com/office/drawing/2010/main" w="9525">
                     <a:solidFill>
                       <a:srgbClr val="000000"/>
                     </a:solidFill>
@@ -12336,7 +12337,7 @@
               </a:ln>
               <a:extLst>
                 <a:ext uri="{91240B29-F687-4f45-9708-019B960494DF}">
-                  <a14:hiddenLine xmlns:a14="http://schemas.microsoft.com/office/drawing/2010/main" xmlns="" w="9525">
+                  <a14:hiddenLine xmlns="" xmlns:a14="http://schemas.microsoft.com/office/drawing/2010/main" w="9525">
                     <a:solidFill>
                       <a:srgbClr val="000000"/>
                     </a:solidFill>
@@ -12476,7 +12477,7 @@
           <a:p>
             <a:fld id="{92FF8978-FE14-CC4A-93A6-934EB06543C0}" type="datetime1">
               <a:rPr lang="en-US" smtClean="0"/>
-              <a:t>7/30/26</a:t>
+              <a:t>8/3/26</a:t>
             </a:fld>
             <a:endParaRPr lang="en-US"/>
           </a:p>
@@ -13909,6 +13910,296 @@
 </file>
 
 <file path=ppt/slides/slide14.xml><?xml version="1.0" encoding="utf-8"?>
+<p:sld xmlns:a="http://schemas.openxmlformats.org/drawingml/2006/main" xmlns:r="http://schemas.openxmlformats.org/officeDocument/2006/relationships" xmlns:p="http://schemas.openxmlformats.org/presentationml/2006/main">
+  <p:cSld>
+    <p:spTree>
+      <p:nvGrpSpPr>
+        <p:cNvPr id="1" name="">
+          <a:extLst>
+            <a:ext uri="{FF2B5EF4-FFF2-40B4-BE49-F238E27FC236}">
+              <a16:creationId xmlns:a16="http://schemas.microsoft.com/office/drawing/2014/main" id="{F1DF574A-7DD4-13AA-21AE-C41D6DC66C78}"/>
+            </a:ext>
+          </a:extLst>
+        </p:cNvPr>
+        <p:cNvGrpSpPr/>
+        <p:nvPr/>
+      </p:nvGrpSpPr>
+      <p:grpSpPr>
+        <a:xfrm>
+          <a:off x="0" y="0"/>
+          <a:ext cx="0" cy="0"/>
+          <a:chOff x="0" y="0"/>
+          <a:chExt cx="0" cy="0"/>
+        </a:xfrm>
+      </p:grpSpPr>
+      <p:sp>
+        <p:nvSpPr>
+          <p:cNvPr id="6146" name="Rectangle 2">
+            <a:extLst>
+              <a:ext uri="{FF2B5EF4-FFF2-40B4-BE49-F238E27FC236}">
+                <a16:creationId xmlns:a16="http://schemas.microsoft.com/office/drawing/2014/main" id="{86E6182E-FB84-1025-DD07-D031D935218B}"/>
+              </a:ext>
+            </a:extLst>
+          </p:cNvPr>
+          <p:cNvSpPr>
+            <a:spLocks noGrp="1" noChangeArrowheads="1"/>
+          </p:cNvSpPr>
+          <p:nvPr>
+            <p:ph type="title"/>
+            <p:custDataLst>
+              <p:tags r:id="rId1"/>
+            </p:custDataLst>
+          </p:nvPr>
+        </p:nvSpPr>
+        <p:spPr>
+          <a:xfrm>
+            <a:off x="1141413" y="284084"/>
+            <a:ext cx="9905998" cy="620791"/>
+          </a:xfrm>
+        </p:spPr>
+        <p:txBody>
+          <a:bodyPr/>
+          <a:lstStyle/>
+          <a:p>
+            <a:pPr algn="ctr"/>
+            <a:r>
+              <a:rPr lang="en-US" dirty="0"/>
+              <a:t>Week 4: Friday</a:t>
+            </a:r>
+          </a:p>
+        </p:txBody>
+      </p:sp>
+      <p:sp>
+        <p:nvSpPr>
+          <p:cNvPr id="6147" name="Rectangle 3">
+            <a:extLst>
+              <a:ext uri="{FF2B5EF4-FFF2-40B4-BE49-F238E27FC236}">
+                <a16:creationId xmlns:a16="http://schemas.microsoft.com/office/drawing/2014/main" id="{93AD5080-21F1-77E4-2468-4EF17E752A9D}"/>
+              </a:ext>
+            </a:extLst>
+          </p:cNvPr>
+          <p:cNvSpPr>
+            <a:spLocks noGrp="1" noChangeArrowheads="1"/>
+          </p:cNvSpPr>
+          <p:nvPr>
+            <p:ph idx="1"/>
+            <p:custDataLst>
+              <p:tags r:id="rId2"/>
+            </p:custDataLst>
+          </p:nvPr>
+        </p:nvSpPr>
+        <p:spPr>
+          <a:xfrm>
+            <a:off x="1294151" y="1098548"/>
+            <a:ext cx="9600522" cy="5475367"/>
+          </a:xfrm>
+        </p:spPr>
+        <p:txBody>
+          <a:bodyPr>
+            <a:normAutofit fontScale="70000" lnSpcReduction="20000"/>
+          </a:bodyPr>
+          <a:lstStyle/>
+          <a:p>
+            <a:r>
+              <a:rPr lang="en-US" dirty="0">
+                <a:latin typeface="Arial" panose="020B0604020202020204" pitchFamily="34" charset="0"/>
+                <a:cs typeface="Arial" panose="020B0604020202020204" pitchFamily="34" charset="0"/>
+              </a:rPr>
+              <a:t>Final week! You got this!!</a:t>
+            </a:r>
+          </a:p>
+          <a:p>
+            <a:r>
+              <a:rPr lang="en-US" dirty="0">
+                <a:latin typeface="Arial" panose="020B0604020202020204" pitchFamily="34" charset="0"/>
+                <a:cs typeface="Arial" panose="020B0604020202020204" pitchFamily="34" charset="0"/>
+              </a:rPr>
+              <a:t>This week:</a:t>
+            </a:r>
+            <a:endParaRPr lang="en-US" b="1" i="1" dirty="0">
+              <a:latin typeface="Arial" panose="020B0604020202020204" pitchFamily="34" charset="0"/>
+              <a:cs typeface="Arial" panose="020B0604020202020204" pitchFamily="34" charset="0"/>
+            </a:endParaRPr>
+          </a:p>
+          <a:p>
+            <a:pPr lvl="1"/>
+            <a:r>
+              <a:rPr lang="en-US" dirty="0">
+                <a:latin typeface="Arial" panose="020B0604020202020204" pitchFamily="34" charset="0"/>
+                <a:cs typeface="Arial" panose="020B0604020202020204" pitchFamily="34" charset="0"/>
+              </a:rPr>
+              <a:t>Mod 3 Written Assignment is Due </a:t>
+            </a:r>
+            <a:r>
+              <a:rPr lang="en-US" b="1" i="1" u="sng" dirty="0">
+                <a:latin typeface="Arial" panose="020B0604020202020204" pitchFamily="34" charset="0"/>
+                <a:cs typeface="Arial" panose="020B0604020202020204" pitchFamily="34" charset="0"/>
+              </a:rPr>
+              <a:t>TONIGHT</a:t>
+            </a:r>
+            <a:r>
+              <a:rPr lang="en-US" dirty="0">
+                <a:latin typeface="Arial" panose="020B0604020202020204" pitchFamily="34" charset="0"/>
+                <a:cs typeface="Arial" panose="020B0604020202020204" pitchFamily="34" charset="0"/>
+              </a:rPr>
+              <a:t>!</a:t>
+            </a:r>
+          </a:p>
+          <a:p>
+            <a:pPr lvl="1"/>
+            <a:r>
+              <a:rPr lang="en-US" dirty="0">
+                <a:latin typeface="Arial" panose="020B0604020202020204" pitchFamily="34" charset="0"/>
+                <a:cs typeface="Arial" panose="020B0604020202020204" pitchFamily="34" charset="0"/>
+              </a:rPr>
+              <a:t>Mod 4 Written Assignment Due THURSDAY NIGHT!</a:t>
+            </a:r>
+          </a:p>
+          <a:p>
+            <a:pPr lvl="1"/>
+            <a:r>
+              <a:rPr lang="en-US" dirty="0">
+                <a:latin typeface="Arial" panose="020B0604020202020204" pitchFamily="34" charset="0"/>
+                <a:cs typeface="Arial" panose="020B0604020202020204" pitchFamily="34" charset="0"/>
+              </a:rPr>
+              <a:t>Final Exam is on Friday</a:t>
+            </a:r>
+          </a:p>
+          <a:p>
+            <a:r>
+              <a:rPr lang="en-US" dirty="0">
+                <a:latin typeface="Arial" panose="020B0604020202020204" pitchFamily="34" charset="0"/>
+                <a:cs typeface="Arial" panose="020B0604020202020204" pitchFamily="34" charset="0"/>
+              </a:rPr>
+              <a:t>Mod 4 Written Assignment.</a:t>
+            </a:r>
+          </a:p>
+          <a:p>
+            <a:pPr lvl="1"/>
+            <a:r>
+              <a:rPr lang="en-US" dirty="0">
+                <a:latin typeface="Arial" panose="020B0604020202020204" pitchFamily="34" charset="0"/>
+                <a:cs typeface="Arial" panose="020B0604020202020204" pitchFamily="34" charset="0"/>
+              </a:rPr>
+              <a:t>Extension is only through Friday night (sorry) because I want to get final grades in Saturday</a:t>
+            </a:r>
+          </a:p>
+          <a:p>
+            <a:r>
+              <a:rPr lang="en-US" dirty="0">
+                <a:latin typeface="Arial" panose="020B0604020202020204" pitchFamily="34" charset="0"/>
+                <a:cs typeface="Arial" panose="020B0604020202020204" pitchFamily="34" charset="0"/>
+              </a:rPr>
+              <a:t>Final Exam</a:t>
+            </a:r>
+          </a:p>
+          <a:p>
+            <a:pPr lvl="1"/>
+            <a:r>
+              <a:rPr lang="en-US" dirty="0">
+                <a:latin typeface="Arial" panose="020B0604020202020204" pitchFamily="34" charset="0"/>
+                <a:cs typeface="Arial" panose="020B0604020202020204" pitchFamily="34" charset="0"/>
+              </a:rPr>
+              <a:t>You will have the full class period (10:30-12:45)</a:t>
+            </a:r>
+          </a:p>
+          <a:p>
+            <a:pPr lvl="1"/>
+            <a:r>
+              <a:rPr lang="en-US" dirty="0">
+                <a:latin typeface="Arial" panose="020B0604020202020204" pitchFamily="34" charset="0"/>
+                <a:cs typeface="Arial" panose="020B0604020202020204" pitchFamily="34" charset="0"/>
+              </a:rPr>
+              <a:t>Will cover the entire course, with an emphasis on modules 3 (Turing Machines) and 4 (Complexity Theory)</a:t>
+            </a:r>
+          </a:p>
+          <a:p>
+            <a:r>
+              <a:rPr lang="en-US" dirty="0">
+                <a:latin typeface="Arial" panose="020B0604020202020204" pitchFamily="34" charset="0"/>
+                <a:cs typeface="Arial" panose="020B0604020202020204" pitchFamily="34" charset="0"/>
+              </a:rPr>
+              <a:t>Lecture recordings from last Fall are posted on Panopto on Canvas</a:t>
+            </a:r>
+          </a:p>
+          <a:p>
+            <a:pPr lvl="1"/>
+            <a:r>
+              <a:rPr lang="en-US" dirty="0">
+                <a:latin typeface="Arial" panose="020B0604020202020204" pitchFamily="34" charset="0"/>
+                <a:cs typeface="Arial" panose="020B0604020202020204" pitchFamily="34" charset="0"/>
+              </a:rPr>
+              <a:t>I posted ALL the videos FYI</a:t>
+            </a:r>
+          </a:p>
+          <a:p>
+            <a:r>
+              <a:rPr lang="en-US" dirty="0">
+                <a:latin typeface="Arial" panose="020B0604020202020204" pitchFamily="34" charset="0"/>
+                <a:cs typeface="Arial" panose="020B0604020202020204" pitchFamily="34" charset="0"/>
+              </a:rPr>
+              <a:t>Please remember that I am asking for NO laptop / phones!</a:t>
+            </a:r>
+          </a:p>
+          <a:p>
+            <a:pPr lvl="1"/>
+            <a:r>
+              <a:rPr lang="en-US" dirty="0">
+                <a:latin typeface="Arial" panose="020B0604020202020204" pitchFamily="34" charset="0"/>
+                <a:cs typeface="Arial" panose="020B0604020202020204" pitchFamily="34" charset="0"/>
+              </a:rPr>
+              <a:t>This makes the learning environment better for everybody. I appreciate it!</a:t>
+            </a:r>
+          </a:p>
+          <a:p>
+            <a:r>
+              <a:rPr lang="en-US" dirty="0">
+                <a:latin typeface="Arial" panose="020B0604020202020204" pitchFamily="34" charset="0"/>
+                <a:cs typeface="Arial" panose="020B0604020202020204" pitchFamily="34" charset="0"/>
+              </a:rPr>
+              <a:t>Attendance continues today as usual.</a:t>
+            </a:r>
+          </a:p>
+          <a:p>
+            <a:r>
+              <a:rPr lang="en-US" dirty="0">
+                <a:latin typeface="Arial" panose="020B0604020202020204" pitchFamily="34" charset="0"/>
+                <a:cs typeface="Arial" panose="020B0604020202020204" pitchFamily="34" charset="0"/>
+              </a:rPr>
+              <a:t>Today we begin the last module</a:t>
+            </a:r>
+          </a:p>
+          <a:p>
+            <a:pPr marL="0" indent="0">
+              <a:buNone/>
+            </a:pPr>
+            <a:endParaRPr lang="en-US" dirty="0">
+              <a:latin typeface="Arial" panose="020B0604020202020204" pitchFamily="34" charset="0"/>
+              <a:cs typeface="Arial" panose="020B0604020202020204" pitchFamily="34" charset="0"/>
+            </a:endParaRPr>
+          </a:p>
+          <a:p>
+            <a:endParaRPr lang="en-US" dirty="0">
+              <a:latin typeface="Arial" panose="020B0604020202020204" pitchFamily="34" charset="0"/>
+              <a:cs typeface="Arial" panose="020B0604020202020204" pitchFamily="34" charset="0"/>
+            </a:endParaRPr>
+          </a:p>
+        </p:txBody>
+      </p:sp>
+    </p:spTree>
+    <p:extLst>
+      <p:ext uri="{BB962C8B-B14F-4D97-AF65-F5344CB8AC3E}">
+        <p14:creationId xmlns:p14="http://schemas.microsoft.com/office/powerpoint/2010/main" val="2964696306"/>
+      </p:ext>
+    </p:extLst>
+  </p:cSld>
+  <p:clrMapOvr>
+    <a:masterClrMapping/>
+  </p:clrMapOvr>
+</p:sld>
+</file>
+
+<file path=ppt/slides/slide15.xml><?xml version="1.0" encoding="utf-8"?>
 <p:sld xmlns:a="http://schemas.openxmlformats.org/drawingml/2006/main" xmlns:r="http://schemas.openxmlformats.org/officeDocument/2006/relationships" xmlns:p="http://schemas.openxmlformats.org/presentationml/2006/main">
   <p:cSld>
     <p:spTree>
@@ -17653,6 +17944,18 @@
 </p:tagLst>
 </file>
 
+<file path=ppt/tags/tag30.xml><?xml version="1.0" encoding="utf-8"?>
+<p:tagLst xmlns:a="http://schemas.openxmlformats.org/drawingml/2006/main" xmlns:r="http://schemas.openxmlformats.org/officeDocument/2006/relationships" xmlns:p="http://schemas.openxmlformats.org/presentationml/2006/main">
+  <p:tag name="_INSTRUCTOR VIEW19C14C36-AC8E-43BC-9DB6-C2AAF774C7DC|PANE__TAG" val="_"/>
+</p:tagLst>
+</file>
+
+<file path=ppt/tags/tag31.xml><?xml version="1.0" encoding="utf-8"?>
+<p:tagLst xmlns:a="http://schemas.openxmlformats.org/drawingml/2006/main" xmlns:r="http://schemas.openxmlformats.org/officeDocument/2006/relationships" xmlns:p="http://schemas.openxmlformats.org/presentationml/2006/main">
+  <p:tag name="_INSTRUCTOR VIEW19C14C36-AC8E-43BC-9DB6-C2AAF774C7DC|PANE__TAG" val="_"/>
+</p:tagLst>
+</file>
+
 <file path=ppt/tags/tag4.xml><?xml version="1.0" encoding="utf-8"?>
 <p:tagLst xmlns:a="http://schemas.openxmlformats.org/drawingml/2006/main" xmlns:r="http://schemas.openxmlformats.org/officeDocument/2006/relationships" xmlns:p="http://schemas.openxmlformats.org/presentationml/2006/main">
   <p:tag name="_INSTRUCTOR VIEW19C14C36-AC8E-43BC-9DB6-C2AAF774C7DC|PANE__TAG" val="_"/>

</xml_diff>